<commit_message>
Generate editable modern slide samples
Co-authored-by: Copilot <223556219+Copilot@users.noreply.github.com>
</commit_message>
<xml_diff>
--- a/samples/pptcreater-overview.pptx
+++ b/samples/pptcreater-overview.pptx
@@ -506,9 +506,7 @@
             <a:r>
               <a:rPr lang="en-US" dirty="0"/>
               <a:t>目的: このpptcreaterツールの価値と使い方を説明し、導入判断につなげる。聴衆: GitHub CopilotやClaude Codeを使う開発者・デザイナー・企画担当。意思決定向けに判断材料、リスク、次アクションを明示する構成です。 タイトル、図、強調箇所が同じ主張を支える構成です。
-Slide 1: 3秒で要点が伝わるスライドを標準化する
-hero-visual: 3秒で伝わるスライド構成のプレビュー
-spark-icon: 品質を示すスパークアイコン</a:t>
+Slide 1: 3秒で要点が伝わるスライドを標準化する</a:t>
             </a:r>
             <a:endParaRPr lang="en-US" dirty="0"/>
           </a:p>
@@ -596,10 +594,8 @@
           <a:p>
             <a:r>
               <a:rPr lang="en-US" dirty="0"/>
-              <a:t>目的、聴衆、構成を最初に確認し、図解・アイコン・検証を後段で自動化します。
-Slide 2: ヒアリングから図解までを1つの作成フローにする
-workflow-diagram: 目的、聴衆、構成、可視化、検証、出力をつなぐ6段階の作成フロー
-workflow-diagram long description: 図は、目的と聴衆の確認から始まり、構成化、可視化、検証、PowerPoint出力へ進む流れを示しています。</a:t>
+              <a:t>目的、聴衆、構成を最初に確認し、図形・アイコン・検証を後段で自動化します。すべてPowerPoint上で編集できるオブジェクトです。
+Slide 2: ヒアリングから図解までを1つの作成フローにする</a:t>
             </a:r>
             <a:endParaRPr lang="en-US" dirty="0"/>
           </a:p>
@@ -687,9 +683,8 @@
           <a:p>
             <a:r>
               <a:rPr lang="en-US" dirty="0"/>
-              <a:t>3秒テスト、視覚階層、アクセシビリティを品質ゲートとして使います。
-Slide 3: 優れたスライドは装飾ではなく情報UIとして設計する
-quality-cards: 3秒テスト、視覚階層、アクセシビリティの3つの品質カード</a:t>
+              <a:t>カード、丸アイコン、テキストはすべてPowerPointオブジェクトなので、後から文字や色を編集できます。
+Slide 3: 優れたスライドは装飾ではなく情報UIとして設計する</a:t>
             </a:r>
             <a:endParaRPr lang="en-US" dirty="0"/>
           </a:p>
@@ -777,10 +772,8 @@
           <a:p>
             <a:r>
               <a:rPr lang="en-US" dirty="0"/>
-              <a:t>テンプレート、アイコン、ポンチ絵、lint、出力を繰り返し使える仕組みにします。
-Slide 4: テンプレートとSVG資産を再利用して継続的に品質を上げる
-rollout: テンプレート、アイコン、ポンチ絵、lint、pptx出力の再利用パス
-shield-icon: アクセシビリティと安全性を示す盾アイコン</a:t>
+              <a:t>ロードマップの線、丸、番号、ラベルも編集可能なPowerPointオブジェクトです。
+Slide 4: テンプレートとSVG資産を再利用して継続的に品質を上げる</a:t>
             </a:r>
             <a:endParaRPr lang="en-US" dirty="0"/>
           </a:p>
@@ -1229,7 +1222,7 @@
                 <a:ea typeface="Yu Gothic" pitchFamily="34" charset="-122"/>
                 <a:cs typeface="Yu Gothic" pitchFamily="34" charset="-120"/>
               </a:rPr>
-              <a:t>用途・聴衆・ボリュームを先に固定し、図解とアクセシビリティ検証をDeckSpecへ組み込みます。</a:t>
+              <a:t>用途・聴衆・ボリュームを先に固定し、編集可能な図形とアクセシビリティ検証をDeckSpecへ組み込みます。</a:t>
             </a:r>
             <a:endParaRPr lang="en-US" sz="2200" dirty="0"/>
           </a:p>
@@ -1237,14 +1230,323 @@
       </p:sp>
       <p:sp>
         <p:nvSpPr>
-          <p:cNvPr id="4" name="Text 2"/>
+          <p:cNvPr id="4" name="Decorative s1-hero-panel" descr="" decorative="1">
+            <a:extLst>
+              <a:ext uri="{C183D7F6-B498-43B3-948B-1728B52AA6E4}">
+                <a16:decorative xmlns:a16="http://schemas.microsoft.com/office/drawing/2014/main">1</a16:decorative>
+              </a:ext>
+            </a:extLst>
+          </p:cNvPr>
+          <p:cNvSpPr/>
+          <p:nvPr/>
+        </p:nvSpPr>
+        <p:spPr>
+          <a:xfrm>
+            <a:off x="6839712" y="713232"/>
+            <a:ext cx="4526280" cy="3246120"/>
+          </a:xfrm>
+          <a:prstGeom prst="roundRect">
+            <a:avLst/>
+          </a:prstGeom>
+          <a:solidFill>
+            <a:srgbClr val="DBEAFE"/>
+          </a:solidFill>
+          <a:ln w="15240">
+            <a:solidFill>
+              <a:srgbClr val="93C5FD"/>
+            </a:solidFill>
+            <a:prstDash val="solid"/>
+          </a:ln>
+        </p:spPr>
+      </p:sp>
+      <p:sp>
+        <p:nvSpPr>
+          <p:cNvPr id="5" name="Decorative s1-hero-card" descr="" decorative="1">
+            <a:extLst>
+              <a:ext uri="{C183D7F6-B498-43B3-948B-1728B52AA6E4}">
+                <a16:decorative xmlns:a16="http://schemas.microsoft.com/office/drawing/2014/main">1</a16:decorative>
+              </a:ext>
+            </a:extLst>
+          </p:cNvPr>
+          <p:cNvSpPr/>
+          <p:nvPr/>
+        </p:nvSpPr>
+        <p:spPr>
+          <a:xfrm>
+            <a:off x="7223760" y="1042416"/>
+            <a:ext cx="1938528" cy="1609344"/>
+          </a:xfrm>
+          <a:prstGeom prst="roundRect">
+            <a:avLst/>
+          </a:prstGeom>
+          <a:solidFill>
+            <a:srgbClr val="FFFFFF"/>
+          </a:solidFill>
+          <a:ln w="12700">
+            <a:solidFill>
+              <a:srgbClr val="93C5FD"/>
+            </a:solidFill>
+            <a:prstDash val="solid"/>
+          </a:ln>
+        </p:spPr>
+      </p:sp>
+      <p:sp>
+        <p:nvSpPr>
+          <p:cNvPr id="6" name="Decorative s1-hero-title-bar" descr="" decorative="1">
+            <a:extLst>
+              <a:ext uri="{C183D7F6-B498-43B3-948B-1728B52AA6E4}">
+                <a16:decorative xmlns:a16="http://schemas.microsoft.com/office/drawing/2014/main">1</a16:decorative>
+              </a:ext>
+            </a:extLst>
+          </p:cNvPr>
+          <p:cNvSpPr/>
+          <p:nvPr/>
+        </p:nvSpPr>
+        <p:spPr>
+          <a:xfrm>
+            <a:off x="7461504" y="1298448"/>
+            <a:ext cx="1298448" cy="128016"/>
+          </a:xfrm>
+          <a:prstGeom prst="roundRect">
+            <a:avLst/>
+          </a:prstGeom>
+          <a:solidFill>
+            <a:srgbClr val="1D4ED8"/>
+          </a:solidFill>
+          <a:ln w="1270">
+            <a:solidFill>
+              <a:srgbClr val="1D4ED8"/>
+            </a:solidFill>
+            <a:prstDash val="solid"/>
+          </a:ln>
+        </p:spPr>
+      </p:sp>
+      <p:sp>
+        <p:nvSpPr>
+          <p:cNvPr id="7" name="Decorative s1-hero-line-1" descr="" decorative="1">
+            <a:extLst>
+              <a:ext uri="{C183D7F6-B498-43B3-948B-1728B52AA6E4}">
+                <a16:decorative xmlns:a16="http://schemas.microsoft.com/office/drawing/2014/main">1</a16:decorative>
+              </a:ext>
+            </a:extLst>
+          </p:cNvPr>
+          <p:cNvSpPr/>
+          <p:nvPr/>
+        </p:nvSpPr>
+        <p:spPr>
+          <a:xfrm>
+            <a:off x="7461504" y="1627632"/>
+            <a:ext cx="1426464" cy="91440"/>
+          </a:xfrm>
+          <a:prstGeom prst="roundRect">
+            <a:avLst/>
+          </a:prstGeom>
+          <a:solidFill>
+            <a:srgbClr val="94A3B8"/>
+          </a:solidFill>
+          <a:ln w="1270">
+            <a:solidFill>
+              <a:srgbClr val="94A3B8"/>
+            </a:solidFill>
+            <a:prstDash val="solid"/>
+          </a:ln>
+        </p:spPr>
+      </p:sp>
+      <p:sp>
+        <p:nvSpPr>
+          <p:cNvPr id="8" name="Decorative s1-hero-line-2" descr="" decorative="1">
+            <a:extLst>
+              <a:ext uri="{C183D7F6-B498-43B3-948B-1728B52AA6E4}">
+                <a16:decorative xmlns:a16="http://schemas.microsoft.com/office/drawing/2014/main">1</a16:decorative>
+              </a:ext>
+            </a:extLst>
+          </p:cNvPr>
+          <p:cNvSpPr/>
+          <p:nvPr/>
+        </p:nvSpPr>
+        <p:spPr>
+          <a:xfrm>
+            <a:off x="7461504" y="1883664"/>
+            <a:ext cx="1078992" cy="91440"/>
+          </a:xfrm>
+          <a:prstGeom prst="roundRect">
+            <a:avLst/>
+          </a:prstGeom>
+          <a:solidFill>
+            <a:srgbClr val="CBD5E1"/>
+          </a:solidFill>
+          <a:ln w="1270">
+            <a:solidFill>
+              <a:srgbClr val="CBD5E1"/>
+            </a:solidFill>
+            <a:prstDash val="solid"/>
+          </a:ln>
+        </p:spPr>
+      </p:sp>
+      <p:sp>
+        <p:nvSpPr>
+          <p:cNvPr id="9" name="Decorative s1-hero-circle" descr="" decorative="1">
+            <a:extLst>
+              <a:ext uri="{C183D7F6-B498-43B3-948B-1728B52AA6E4}">
+                <a16:decorative xmlns:a16="http://schemas.microsoft.com/office/drawing/2014/main">1</a16:decorative>
+              </a:ext>
+            </a:extLst>
+          </p:cNvPr>
+          <p:cNvSpPr/>
+          <p:nvPr/>
+        </p:nvSpPr>
+        <p:spPr>
+          <a:xfrm>
+            <a:off x="9473184" y="1152144"/>
+            <a:ext cx="1389888" cy="1389888"/>
+          </a:xfrm>
+          <a:prstGeom prst="ellipse">
+            <a:avLst/>
+          </a:prstGeom>
+          <a:solidFill>
+            <a:srgbClr val="1D4ED8"/>
+          </a:solidFill>
+          <a:ln w="12700">
+            <a:solidFill>
+              <a:srgbClr val="1D4ED8"/>
+            </a:solidFill>
+            <a:prstDash val="solid"/>
+          </a:ln>
+        </p:spPr>
+      </p:sp>
+      <p:sp>
+        <p:nvSpPr>
+          <p:cNvPr id="10" name="Text 8"/>
+          <p:cNvSpPr/>
+          <p:nvPr/>
+        </p:nvSpPr>
+        <p:spPr>
+          <a:xfrm>
+            <a:off x="9473184" y="1362456"/>
+            <a:ext cx="1389888" cy="530352"/>
+          </a:xfrm>
+          <a:prstGeom prst="rect">
+            <a:avLst/>
+          </a:prstGeom>
+          <a:noFill/>
+          <a:ln/>
+        </p:spPr>
+        <p:txBody>
+          <a:bodyPr wrap="square" lIns="254" tIns="254" rIns="254" bIns="254" rtlCol="0" anchor="ctr">
+            <a:normAutofit/>
+          </a:bodyPr>
+          <a:lstStyle/>
+          <a:p>
+            <a:pPr algn="ctr" indent="0" marL="0">
+              <a:buNone/>
+            </a:pPr>
+            <a:r>
+              <a:rPr lang="en-US" sz="3400" b="1" dirty="0">
+                <a:solidFill>
+                  <a:srgbClr val="FFFFFF"/>
+                </a:solidFill>
+                <a:latin typeface="Yu Gothic" pitchFamily="34" charset="0"/>
+                <a:ea typeface="Yu Gothic" pitchFamily="34" charset="-122"/>
+                <a:cs typeface="Yu Gothic" pitchFamily="34" charset="-120"/>
+              </a:rPr>
+              <a:t>→</a:t>
+            </a:r>
+            <a:endParaRPr lang="en-US" sz="3400" dirty="0"/>
+          </a:p>
+        </p:txBody>
+      </p:sp>
+      <p:sp>
+        <p:nvSpPr>
+          <p:cNvPr id="11" name="Text 9"/>
+          <p:cNvSpPr/>
+          <p:nvPr/>
+        </p:nvSpPr>
+        <p:spPr>
+          <a:xfrm>
+            <a:off x="9290304" y="2770632"/>
+            <a:ext cx="1554480" cy="320040"/>
+          </a:xfrm>
+          <a:prstGeom prst="rect">
+            <a:avLst/>
+          </a:prstGeom>
+          <a:noFill/>
+          <a:ln/>
+        </p:spPr>
+        <p:txBody>
+          <a:bodyPr wrap="square" lIns="254" tIns="254" rIns="254" bIns="254" rtlCol="0" anchor="ctr">
+            <a:normAutofit/>
+          </a:bodyPr>
+          <a:lstStyle/>
+          <a:p>
+            <a:pPr algn="ctr" indent="0" marL="0">
+              <a:buNone/>
+            </a:pPr>
+            <a:r>
+              <a:rPr lang="en-US" sz="2200" b="1" dirty="0">
+                <a:solidFill>
+                  <a:srgbClr val="0F172A"/>
+                </a:solidFill>
+                <a:latin typeface="Yu Gothic" pitchFamily="34" charset="0"/>
+                <a:ea typeface="Yu Gothic" pitchFamily="34" charset="-122"/>
+                <a:cs typeface="Yu Gothic" pitchFamily="34" charset="-120"/>
+              </a:rPr>
+              <a:t>3 sec</a:t>
+            </a:r>
+            <a:endParaRPr lang="en-US" sz="2200" dirty="0"/>
+          </a:p>
+        </p:txBody>
+      </p:sp>
+      <p:sp>
+        <p:nvSpPr>
+          <p:cNvPr id="12" name="Text 10"/>
+          <p:cNvSpPr/>
+          <p:nvPr/>
+        </p:nvSpPr>
+        <p:spPr>
+          <a:xfrm>
+            <a:off x="8915400" y="3136392"/>
+            <a:ext cx="2331720" cy="292608"/>
+          </a:xfrm>
+          <a:prstGeom prst="rect">
+            <a:avLst/>
+          </a:prstGeom>
+          <a:noFill/>
+          <a:ln/>
+        </p:spPr>
+        <p:txBody>
+          <a:bodyPr wrap="square" lIns="254" tIns="254" rIns="254" bIns="254" rtlCol="0" anchor="ctr">
+            <a:normAutofit/>
+          </a:bodyPr>
+          <a:lstStyle/>
+          <a:p>
+            <a:pPr algn="ctr" indent="0" marL="0">
+              <a:buNone/>
+            </a:pPr>
+            <a:r>
+              <a:rPr lang="en-US" sz="1400" dirty="0">
+                <a:solidFill>
+                  <a:srgbClr val="334155"/>
+                </a:solidFill>
+                <a:latin typeface="Yu Gothic" pitchFamily="34" charset="0"/>
+                <a:ea typeface="Yu Gothic" pitchFamily="34" charset="-122"/>
+                <a:cs typeface="Yu Gothic" pitchFamily="34" charset="-120"/>
+              </a:rPr>
+              <a:t>One message</a:t>
+            </a:r>
+            <a:endParaRPr lang="en-US" sz="1400" dirty="0"/>
+          </a:p>
+        </p:txBody>
+      </p:sp>
+      <p:sp>
+        <p:nvSpPr>
+          <p:cNvPr id="13" name="Text 11"/>
           <p:cNvSpPr/>
           <p:nvPr/>
         </p:nvSpPr>
         <p:spPr>
           <a:xfrm>
             <a:off x="658368" y="2743200"/>
-            <a:ext cx="4023360" cy="384048"/>
+            <a:ext cx="5394960" cy="566928"/>
           </a:xfrm>
           <a:prstGeom prst="rect">
             <a:avLst/>
@@ -1276,76 +1578,88 @@
           </a:p>
         </p:txBody>
       </p:sp>
-      <p:pic>
-        <p:nvPicPr>
-          <p:cNvPr id="5" name="Image 0" descr="3秒で伝わるスライド構成のプレビュー">    </p:cNvPr>
-          <p:cNvPicPr>
-            <a:picLocks noChangeAspect="1"/>
-          </p:cNvPicPr>
-          <p:nvPr/>
-        </p:nvPicPr>
-        <p:blipFill>
-          <a:blip r:embed="rId1">
+      <p:sp>
+        <p:nvSpPr>
+          <p:cNvPr id="14" name="Decorative s1-spark-badge" descr="" decorative="1">
             <a:extLst>
-              <a:ext uri="{96DAC541-7B7A-43D3-8B79-37D633B846F1}">
-                <asvg:svgBlip xmlns:asvg="http://schemas.microsoft.com/office/drawing/2016/SVG/main" r:embed="rId2"/>
+              <a:ext uri="{C183D7F6-B498-43B3-948B-1728B52AA6E4}">
+                <a16:decorative xmlns:a16="http://schemas.microsoft.com/office/drawing/2014/main">1</a16:decorative>
               </a:ext>
             </a:extLst>
-          </a:blip>
-          <a:stretch>
-            <a:fillRect/>
-          </a:stretch>
-        </p:blipFill>
-        <p:spPr>
-          <a:xfrm>
-            <a:off x="6903720" y="713232"/>
-            <a:ext cx="4480560" cy="2926080"/>
-          </a:xfrm>
-          <a:prstGeom prst="rect">
-            <a:avLst/>
-          </a:prstGeom>
-        </p:spPr>
-      </p:pic>
-      <p:pic>
-        <p:nvPicPr>
-          <p:cNvPr id="6" name="Image 1" descr="品質を示すスパークアイコン">    </p:cNvPr>
-          <p:cNvPicPr>
-            <a:picLocks noChangeAspect="1"/>
-          </p:cNvPicPr>
-          <p:nvPr/>
-        </p:nvPicPr>
-        <p:blipFill>
-          <a:blip r:embed="rId3">
-            <a:extLst>
-              <a:ext uri="{96DAC541-7B7A-43D3-8B79-37D633B846F1}">
-                <asvg:svgBlip xmlns:asvg="http://schemas.microsoft.com/office/drawing/2016/SVG/main" r:embed="rId4"/>
-              </a:ext>
-            </a:extLst>
-          </a:blip>
-          <a:stretch>
-            <a:fillRect/>
-          </a:stretch>
-        </p:blipFill>
+          </p:cNvPr>
+          <p:cNvSpPr/>
+          <p:nvPr/>
+        </p:nvSpPr>
         <p:spPr>
           <a:xfrm>
             <a:off x="676656" y="3493008"/>
             <a:ext cx="493776" cy="493776"/>
           </a:xfrm>
-          <a:prstGeom prst="rect">
-            <a:avLst/>
-          </a:prstGeom>
-        </p:spPr>
-      </p:pic>
-      <p:sp>
-        <p:nvSpPr>
-          <p:cNvPr id="7" name="Text 3"/>
+          <a:prstGeom prst="ellipse">
+            <a:avLst/>
+          </a:prstGeom>
+          <a:solidFill>
+            <a:srgbClr val="7C3AED"/>
+          </a:solidFill>
+          <a:ln w="12700">
+            <a:solidFill>
+              <a:srgbClr val="7C3AED"/>
+            </a:solidFill>
+            <a:prstDash val="solid"/>
+          </a:ln>
+        </p:spPr>
+      </p:sp>
+      <p:sp>
+        <p:nvSpPr>
+          <p:cNvPr id="15" name="Text 13"/>
+          <p:cNvSpPr/>
+          <p:nvPr/>
+        </p:nvSpPr>
+        <p:spPr>
+          <a:xfrm>
+            <a:off x="676656" y="3557016"/>
+            <a:ext cx="493776" cy="256032"/>
+          </a:xfrm>
+          <a:prstGeom prst="rect">
+            <a:avLst/>
+          </a:prstGeom>
+          <a:noFill/>
+          <a:ln/>
+        </p:spPr>
+        <p:txBody>
+          <a:bodyPr wrap="square" lIns="254" tIns="254" rIns="254" bIns="254" rtlCol="0" anchor="ctr">
+            <a:normAutofit/>
+          </a:bodyPr>
+          <a:lstStyle/>
+          <a:p>
+            <a:pPr algn="ctr" indent="0" marL="0">
+              <a:buNone/>
+            </a:pPr>
+            <a:r>
+              <a:rPr lang="en-US" sz="1800" dirty="0">
+                <a:solidFill>
+                  <a:srgbClr val="FFFFFF"/>
+                </a:solidFill>
+                <a:latin typeface="Yu Gothic" pitchFamily="34" charset="0"/>
+                <a:ea typeface="Yu Gothic" pitchFamily="34" charset="-122"/>
+                <a:cs typeface="Yu Gothic" pitchFamily="34" charset="-120"/>
+              </a:rPr>
+              <a:t>✦</a:t>
+            </a:r>
+            <a:endParaRPr lang="en-US" sz="1800" dirty="0"/>
+          </a:p>
+        </p:txBody>
+      </p:sp>
+      <p:sp>
+        <p:nvSpPr>
+          <p:cNvPr id="16" name="Text 14"/>
           <p:cNvSpPr/>
           <p:nvPr/>
         </p:nvSpPr>
         <p:spPr>
           <a:xfrm>
             <a:off x="1298448" y="3566160"/>
-            <a:ext cx="6126480" cy="347472"/>
+            <a:ext cx="6720840" cy="530352"/>
           </a:xfrm>
           <a:prstGeom prst="rect">
             <a:avLst/>
@@ -1371,7 +1685,7 @@
                 <a:ea typeface="Yu Gothic" pitchFamily="34" charset="-122"/>
                 <a:cs typeface="Yu Gothic" pitchFamily="34" charset="-120"/>
               </a:rPr>
-              <a:t>Mode: decision / 1 slide = 1 message / high signal-to-noise / accessible by default</a:t>
+              <a:t>Mode: decision / 1 slide = 1 message / high signal-to-noise / editable PPT objects</a:t>
             </a:r>
             <a:endParaRPr lang="en-US" sz="1300" dirty="0"/>
           </a:p>
@@ -1450,39 +1764,658 @@
           </a:p>
         </p:txBody>
       </p:sp>
-      <p:pic>
-        <p:nvPicPr>
-          <p:cNvPr id="3" name="Image 0" descr="目的、聴衆、構成、可視化、検証、出力をつなぐ6段階の作成フロー">    </p:cNvPr>
-          <p:cNvPicPr>
-            <a:picLocks noChangeAspect="1"/>
-          </p:cNvPicPr>
-          <p:nvPr/>
-        </p:nvPicPr>
-        <p:blipFill>
-          <a:blip r:embed="rId1">
+      <p:sp>
+        <p:nvSpPr>
+          <p:cNvPr id="3" name="Decorative s2-workflow-bg" descr="" decorative="1">
             <a:extLst>
-              <a:ext uri="{96DAC541-7B7A-43D3-8B79-37D633B846F1}">
-                <asvg:svgBlip xmlns:asvg="http://schemas.microsoft.com/office/drawing/2016/SVG/main" r:embed="rId2"/>
+              <a:ext uri="{C183D7F6-B498-43B3-948B-1728B52AA6E4}">
+                <a16:decorative xmlns:a16="http://schemas.microsoft.com/office/drawing/2014/main">1</a16:decorative>
               </a:ext>
             </a:extLst>
-          </a:blip>
-          <a:stretch>
-            <a:fillRect/>
-          </a:stretch>
-        </p:blipFill>
-        <p:spPr>
-          <a:xfrm>
-            <a:off x="713232" y="1325880"/>
-            <a:ext cx="10698480" cy="3886200"/>
-          </a:xfrm>
-          <a:prstGeom prst="rect">
-            <a:avLst/>
-          </a:prstGeom>
-        </p:spPr>
-      </p:pic>
-      <p:sp>
-        <p:nvSpPr>
-          <p:cNvPr id="4" name="Text 1"/>
+          </p:cNvPr>
+          <p:cNvSpPr/>
+          <p:nvPr/>
+        </p:nvSpPr>
+        <p:spPr>
+          <a:xfrm>
+            <a:off x="713232" y="1353312"/>
+            <a:ext cx="10735056" cy="3822192"/>
+          </a:xfrm>
+          <a:prstGeom prst="roundRect">
+            <a:avLst/>
+          </a:prstGeom>
+          <a:solidFill>
+            <a:srgbClr val="FFFFFF"/>
+          </a:solidFill>
+          <a:ln w="12700">
+            <a:solidFill>
+              <a:srgbClr val="CBD5E1"/>
+            </a:solidFill>
+            <a:prstDash val="solid"/>
+          </a:ln>
+        </p:spPr>
+      </p:sp>
+      <p:sp>
+        <p:nvSpPr>
+          <p:cNvPr id="4" name="Decorative s2-workflow-node-0" descr="" decorative="1">
+            <a:extLst>
+              <a:ext uri="{C183D7F6-B498-43B3-948B-1728B52AA6E4}">
+                <a16:decorative xmlns:a16="http://schemas.microsoft.com/office/drawing/2014/main">1</a16:decorative>
+              </a:ext>
+            </a:extLst>
+          </p:cNvPr>
+          <p:cNvSpPr/>
+          <p:nvPr/>
+        </p:nvSpPr>
+        <p:spPr>
+          <a:xfrm>
+            <a:off x="987552" y="2359152"/>
+            <a:ext cx="1133856" cy="804672"/>
+          </a:xfrm>
+          <a:prstGeom prst="roundRect">
+            <a:avLst/>
+          </a:prstGeom>
+          <a:solidFill>
+            <a:srgbClr val="DBEAFE"/>
+          </a:solidFill>
+          <a:ln w="15240">
+            <a:solidFill>
+              <a:srgbClr val="2563EB"/>
+            </a:solidFill>
+            <a:prstDash val="solid"/>
+          </a:ln>
+        </p:spPr>
+      </p:sp>
+      <p:sp>
+        <p:nvSpPr>
+          <p:cNvPr id="5" name="Text 3"/>
+          <p:cNvSpPr/>
+          <p:nvPr/>
+        </p:nvSpPr>
+        <p:spPr>
+          <a:xfrm>
+            <a:off x="987552" y="2587752"/>
+            <a:ext cx="1133856" cy="256032"/>
+          </a:xfrm>
+          <a:prstGeom prst="rect">
+            <a:avLst/>
+          </a:prstGeom>
+          <a:noFill/>
+          <a:ln/>
+        </p:spPr>
+        <p:txBody>
+          <a:bodyPr wrap="square" lIns="254" tIns="254" rIns="254" bIns="254" rtlCol="0" anchor="ctr">
+            <a:normAutofit/>
+          </a:bodyPr>
+          <a:lstStyle/>
+          <a:p>
+            <a:pPr algn="ctr" indent="0" marL="0">
+              <a:buNone/>
+            </a:pPr>
+            <a:r>
+              <a:rPr lang="en-US" sz="1500" dirty="0">
+                <a:solidFill>
+                  <a:srgbClr val="0F172A"/>
+                </a:solidFill>
+                <a:latin typeface="Yu Gothic" pitchFamily="34" charset="0"/>
+                <a:ea typeface="Yu Gothic" pitchFamily="34" charset="-122"/>
+                <a:cs typeface="Yu Gothic" pitchFamily="34" charset="-120"/>
+              </a:rPr>
+              <a:t>目的</a:t>
+            </a:r>
+            <a:endParaRPr lang="en-US" sz="1500" dirty="0"/>
+          </a:p>
+        </p:txBody>
+      </p:sp>
+      <p:sp>
+        <p:nvSpPr>
+          <p:cNvPr id="6" name="Decorative s2-workflow-arrow-0" descr="" decorative="1">
+            <a:extLst>
+              <a:ext uri="{C183D7F6-B498-43B3-948B-1728B52AA6E4}">
+                <a16:decorative xmlns:a16="http://schemas.microsoft.com/office/drawing/2014/main">1</a16:decorative>
+              </a:ext>
+            </a:extLst>
+          </p:cNvPr>
+          <p:cNvSpPr/>
+          <p:nvPr/>
+        </p:nvSpPr>
+        <p:spPr>
+          <a:xfrm>
+            <a:off x="2103120" y="2761488"/>
+            <a:ext cx="475488" cy="9144"/>
+          </a:xfrm>
+          <a:prstGeom prst="line">
+            <a:avLst/>
+          </a:prstGeom>
+          <a:ln w="25400">
+            <a:solidFill>
+              <a:srgbClr val="64748B"/>
+            </a:solidFill>
+            <a:prstDash val="solid"/>
+            <a:tailEnd type="triangle"/>
+          </a:ln>
+        </p:spPr>
+      </p:sp>
+      <p:sp>
+        <p:nvSpPr>
+          <p:cNvPr id="7" name="Decorative s2-workflow-node-1" descr="" decorative="1">
+            <a:extLst>
+              <a:ext uri="{C183D7F6-B498-43B3-948B-1728B52AA6E4}">
+                <a16:decorative xmlns:a16="http://schemas.microsoft.com/office/drawing/2014/main">1</a16:decorative>
+              </a:ext>
+            </a:extLst>
+          </p:cNvPr>
+          <p:cNvSpPr/>
+          <p:nvPr/>
+        </p:nvSpPr>
+        <p:spPr>
+          <a:xfrm>
+            <a:off x="2651760" y="2359152"/>
+            <a:ext cx="1133856" cy="804672"/>
+          </a:xfrm>
+          <a:prstGeom prst="roundRect">
+            <a:avLst/>
+          </a:prstGeom>
+          <a:solidFill>
+            <a:srgbClr val="DBEAFE"/>
+          </a:solidFill>
+          <a:ln w="15240">
+            <a:solidFill>
+              <a:srgbClr val="2563EB"/>
+            </a:solidFill>
+            <a:prstDash val="solid"/>
+          </a:ln>
+        </p:spPr>
+      </p:sp>
+      <p:sp>
+        <p:nvSpPr>
+          <p:cNvPr id="8" name="Text 6"/>
+          <p:cNvSpPr/>
+          <p:nvPr/>
+        </p:nvSpPr>
+        <p:spPr>
+          <a:xfrm>
+            <a:off x="2651760" y="2587752"/>
+            <a:ext cx="1133856" cy="256032"/>
+          </a:xfrm>
+          <a:prstGeom prst="rect">
+            <a:avLst/>
+          </a:prstGeom>
+          <a:noFill/>
+          <a:ln/>
+        </p:spPr>
+        <p:txBody>
+          <a:bodyPr wrap="square" lIns="254" tIns="254" rIns="254" bIns="254" rtlCol="0" anchor="ctr">
+            <a:normAutofit/>
+          </a:bodyPr>
+          <a:lstStyle/>
+          <a:p>
+            <a:pPr algn="ctr" indent="0" marL="0">
+              <a:buNone/>
+            </a:pPr>
+            <a:r>
+              <a:rPr lang="en-US" sz="1500" dirty="0">
+                <a:solidFill>
+                  <a:srgbClr val="0F172A"/>
+                </a:solidFill>
+                <a:latin typeface="Yu Gothic" pitchFamily="34" charset="0"/>
+                <a:ea typeface="Yu Gothic" pitchFamily="34" charset="-122"/>
+                <a:cs typeface="Yu Gothic" pitchFamily="34" charset="-120"/>
+              </a:rPr>
+              <a:t>聴衆</a:t>
+            </a:r>
+            <a:endParaRPr lang="en-US" sz="1500" dirty="0"/>
+          </a:p>
+        </p:txBody>
+      </p:sp>
+      <p:sp>
+        <p:nvSpPr>
+          <p:cNvPr id="9" name="Decorative s2-workflow-arrow-1" descr="" decorative="1">
+            <a:extLst>
+              <a:ext uri="{C183D7F6-B498-43B3-948B-1728B52AA6E4}">
+                <a16:decorative xmlns:a16="http://schemas.microsoft.com/office/drawing/2014/main">1</a16:decorative>
+              </a:ext>
+            </a:extLst>
+          </p:cNvPr>
+          <p:cNvSpPr/>
+          <p:nvPr/>
+        </p:nvSpPr>
+        <p:spPr>
+          <a:xfrm>
+            <a:off x="3767328" y="2761488"/>
+            <a:ext cx="475488" cy="9144"/>
+          </a:xfrm>
+          <a:prstGeom prst="line">
+            <a:avLst/>
+          </a:prstGeom>
+          <a:ln w="25400">
+            <a:solidFill>
+              <a:srgbClr val="64748B"/>
+            </a:solidFill>
+            <a:prstDash val="solid"/>
+            <a:tailEnd type="triangle"/>
+          </a:ln>
+        </p:spPr>
+      </p:sp>
+      <p:sp>
+        <p:nvSpPr>
+          <p:cNvPr id="10" name="Decorative s2-workflow-node-2" descr="" decorative="1">
+            <a:extLst>
+              <a:ext uri="{C183D7F6-B498-43B3-948B-1728B52AA6E4}">
+                <a16:decorative xmlns:a16="http://schemas.microsoft.com/office/drawing/2014/main">1</a16:decorative>
+              </a:ext>
+            </a:extLst>
+          </p:cNvPr>
+          <p:cNvSpPr/>
+          <p:nvPr/>
+        </p:nvSpPr>
+        <p:spPr>
+          <a:xfrm>
+            <a:off x="4315968" y="2359152"/>
+            <a:ext cx="1133856" cy="804672"/>
+          </a:xfrm>
+          <a:prstGeom prst="roundRect">
+            <a:avLst/>
+          </a:prstGeom>
+          <a:solidFill>
+            <a:srgbClr val="ECFEFF"/>
+          </a:solidFill>
+          <a:ln w="15240">
+            <a:solidFill>
+              <a:srgbClr val="0891B2"/>
+            </a:solidFill>
+            <a:prstDash val="solid"/>
+          </a:ln>
+        </p:spPr>
+      </p:sp>
+      <p:sp>
+        <p:nvSpPr>
+          <p:cNvPr id="11" name="Text 9"/>
+          <p:cNvSpPr/>
+          <p:nvPr/>
+        </p:nvSpPr>
+        <p:spPr>
+          <a:xfrm>
+            <a:off x="4315968" y="2587752"/>
+            <a:ext cx="1133856" cy="256032"/>
+          </a:xfrm>
+          <a:prstGeom prst="rect">
+            <a:avLst/>
+          </a:prstGeom>
+          <a:noFill/>
+          <a:ln/>
+        </p:spPr>
+        <p:txBody>
+          <a:bodyPr wrap="square" lIns="254" tIns="254" rIns="254" bIns="254" rtlCol="0" anchor="ctr">
+            <a:normAutofit/>
+          </a:bodyPr>
+          <a:lstStyle/>
+          <a:p>
+            <a:pPr algn="ctr" indent="0" marL="0">
+              <a:buNone/>
+            </a:pPr>
+            <a:r>
+              <a:rPr lang="en-US" sz="1500" dirty="0">
+                <a:solidFill>
+                  <a:srgbClr val="0F172A"/>
+                </a:solidFill>
+                <a:latin typeface="Yu Gothic" pitchFamily="34" charset="0"/>
+                <a:ea typeface="Yu Gothic" pitchFamily="34" charset="-122"/>
+                <a:cs typeface="Yu Gothic" pitchFamily="34" charset="-120"/>
+              </a:rPr>
+              <a:t>構成</a:t>
+            </a:r>
+            <a:endParaRPr lang="en-US" sz="1500" dirty="0"/>
+          </a:p>
+        </p:txBody>
+      </p:sp>
+      <p:sp>
+        <p:nvSpPr>
+          <p:cNvPr id="12" name="Decorative s2-workflow-arrow-2" descr="" decorative="1">
+            <a:extLst>
+              <a:ext uri="{C183D7F6-B498-43B3-948B-1728B52AA6E4}">
+                <a16:decorative xmlns:a16="http://schemas.microsoft.com/office/drawing/2014/main">1</a16:decorative>
+              </a:ext>
+            </a:extLst>
+          </p:cNvPr>
+          <p:cNvSpPr/>
+          <p:nvPr/>
+        </p:nvSpPr>
+        <p:spPr>
+          <a:xfrm>
+            <a:off x="5431536" y="2761488"/>
+            <a:ext cx="475488" cy="9144"/>
+          </a:xfrm>
+          <a:prstGeom prst="line">
+            <a:avLst/>
+          </a:prstGeom>
+          <a:ln w="25400">
+            <a:solidFill>
+              <a:srgbClr val="64748B"/>
+            </a:solidFill>
+            <a:prstDash val="solid"/>
+            <a:tailEnd type="triangle"/>
+          </a:ln>
+        </p:spPr>
+      </p:sp>
+      <p:sp>
+        <p:nvSpPr>
+          <p:cNvPr id="13" name="Decorative s2-workflow-node-3" descr="" decorative="1">
+            <a:extLst>
+              <a:ext uri="{C183D7F6-B498-43B3-948B-1728B52AA6E4}">
+                <a16:decorative xmlns:a16="http://schemas.microsoft.com/office/drawing/2014/main">1</a16:decorative>
+              </a:ext>
+            </a:extLst>
+          </p:cNvPr>
+          <p:cNvSpPr/>
+          <p:nvPr/>
+        </p:nvSpPr>
+        <p:spPr>
+          <a:xfrm>
+            <a:off x="5980176" y="2359152"/>
+            <a:ext cx="1133856" cy="804672"/>
+          </a:xfrm>
+          <a:prstGeom prst="roundRect">
+            <a:avLst/>
+          </a:prstGeom>
+          <a:solidFill>
+            <a:srgbClr val="ECFEFF"/>
+          </a:solidFill>
+          <a:ln w="15240">
+            <a:solidFill>
+              <a:srgbClr val="0891B2"/>
+            </a:solidFill>
+            <a:prstDash val="solid"/>
+          </a:ln>
+        </p:spPr>
+      </p:sp>
+      <p:sp>
+        <p:nvSpPr>
+          <p:cNvPr id="14" name="Text 12"/>
+          <p:cNvSpPr/>
+          <p:nvPr/>
+        </p:nvSpPr>
+        <p:spPr>
+          <a:xfrm>
+            <a:off x="5980176" y="2587752"/>
+            <a:ext cx="1133856" cy="256032"/>
+          </a:xfrm>
+          <a:prstGeom prst="rect">
+            <a:avLst/>
+          </a:prstGeom>
+          <a:noFill/>
+          <a:ln/>
+        </p:spPr>
+        <p:txBody>
+          <a:bodyPr wrap="square" lIns="254" tIns="254" rIns="254" bIns="254" rtlCol="0" anchor="ctr">
+            <a:normAutofit/>
+          </a:bodyPr>
+          <a:lstStyle/>
+          <a:p>
+            <a:pPr algn="ctr" indent="0" marL="0">
+              <a:buNone/>
+            </a:pPr>
+            <a:r>
+              <a:rPr lang="en-US" sz="1500" dirty="0">
+                <a:solidFill>
+                  <a:srgbClr val="0F172A"/>
+                </a:solidFill>
+                <a:latin typeface="Yu Gothic" pitchFamily="34" charset="0"/>
+                <a:ea typeface="Yu Gothic" pitchFamily="34" charset="-122"/>
+                <a:cs typeface="Yu Gothic" pitchFamily="34" charset="-120"/>
+              </a:rPr>
+              <a:t>可視化</a:t>
+            </a:r>
+            <a:endParaRPr lang="en-US" sz="1500" dirty="0"/>
+          </a:p>
+        </p:txBody>
+      </p:sp>
+      <p:sp>
+        <p:nvSpPr>
+          <p:cNvPr id="15" name="Decorative s2-workflow-arrow-3" descr="" decorative="1">
+            <a:extLst>
+              <a:ext uri="{C183D7F6-B498-43B3-948B-1728B52AA6E4}">
+                <a16:decorative xmlns:a16="http://schemas.microsoft.com/office/drawing/2014/main">1</a16:decorative>
+              </a:ext>
+            </a:extLst>
+          </p:cNvPr>
+          <p:cNvSpPr/>
+          <p:nvPr/>
+        </p:nvSpPr>
+        <p:spPr>
+          <a:xfrm>
+            <a:off x="7095744" y="2761488"/>
+            <a:ext cx="475488" cy="9144"/>
+          </a:xfrm>
+          <a:prstGeom prst="line">
+            <a:avLst/>
+          </a:prstGeom>
+          <a:ln w="25400">
+            <a:solidFill>
+              <a:srgbClr val="64748B"/>
+            </a:solidFill>
+            <a:prstDash val="solid"/>
+            <a:tailEnd type="triangle"/>
+          </a:ln>
+        </p:spPr>
+      </p:sp>
+      <p:sp>
+        <p:nvSpPr>
+          <p:cNvPr id="16" name="Decorative s2-workflow-node-4" descr="" decorative="1">
+            <a:extLst>
+              <a:ext uri="{C183D7F6-B498-43B3-948B-1728B52AA6E4}">
+                <a16:decorative xmlns:a16="http://schemas.microsoft.com/office/drawing/2014/main">1</a16:decorative>
+              </a:ext>
+            </a:extLst>
+          </p:cNvPr>
+          <p:cNvSpPr/>
+          <p:nvPr/>
+        </p:nvSpPr>
+        <p:spPr>
+          <a:xfrm>
+            <a:off x="7644384" y="2359152"/>
+            <a:ext cx="1133856" cy="804672"/>
+          </a:xfrm>
+          <a:prstGeom prst="roundRect">
+            <a:avLst/>
+          </a:prstGeom>
+          <a:solidFill>
+            <a:srgbClr val="DCFCE7"/>
+          </a:solidFill>
+          <a:ln w="15240">
+            <a:solidFill>
+              <a:srgbClr val="059669"/>
+            </a:solidFill>
+            <a:prstDash val="solid"/>
+          </a:ln>
+        </p:spPr>
+      </p:sp>
+      <p:sp>
+        <p:nvSpPr>
+          <p:cNvPr id="17" name="Text 15"/>
+          <p:cNvSpPr/>
+          <p:nvPr/>
+        </p:nvSpPr>
+        <p:spPr>
+          <a:xfrm>
+            <a:off x="7644384" y="2587752"/>
+            <a:ext cx="1133856" cy="256032"/>
+          </a:xfrm>
+          <a:prstGeom prst="rect">
+            <a:avLst/>
+          </a:prstGeom>
+          <a:noFill/>
+          <a:ln/>
+        </p:spPr>
+        <p:txBody>
+          <a:bodyPr wrap="square" lIns="254" tIns="254" rIns="254" bIns="254" rtlCol="0" anchor="ctr">
+            <a:normAutofit/>
+          </a:bodyPr>
+          <a:lstStyle/>
+          <a:p>
+            <a:pPr algn="ctr" indent="0" marL="0">
+              <a:buNone/>
+            </a:pPr>
+            <a:r>
+              <a:rPr lang="en-US" sz="1500" dirty="0">
+                <a:solidFill>
+                  <a:srgbClr val="0F172A"/>
+                </a:solidFill>
+                <a:latin typeface="Yu Gothic" pitchFamily="34" charset="0"/>
+                <a:ea typeface="Yu Gothic" pitchFamily="34" charset="-122"/>
+                <a:cs typeface="Yu Gothic" pitchFamily="34" charset="-120"/>
+              </a:rPr>
+              <a:t>検証</a:t>
+            </a:r>
+            <a:endParaRPr lang="en-US" sz="1500" dirty="0"/>
+          </a:p>
+        </p:txBody>
+      </p:sp>
+      <p:sp>
+        <p:nvSpPr>
+          <p:cNvPr id="18" name="Decorative s2-workflow-arrow-4" descr="" decorative="1">
+            <a:extLst>
+              <a:ext uri="{C183D7F6-B498-43B3-948B-1728B52AA6E4}">
+                <a16:decorative xmlns:a16="http://schemas.microsoft.com/office/drawing/2014/main">1</a16:decorative>
+              </a:ext>
+            </a:extLst>
+          </p:cNvPr>
+          <p:cNvSpPr/>
+          <p:nvPr/>
+        </p:nvSpPr>
+        <p:spPr>
+          <a:xfrm>
+            <a:off x="8759952" y="2761488"/>
+            <a:ext cx="475488" cy="9144"/>
+          </a:xfrm>
+          <a:prstGeom prst="line">
+            <a:avLst/>
+          </a:prstGeom>
+          <a:ln w="25400">
+            <a:solidFill>
+              <a:srgbClr val="64748B"/>
+            </a:solidFill>
+            <a:prstDash val="solid"/>
+            <a:tailEnd type="triangle"/>
+          </a:ln>
+        </p:spPr>
+      </p:sp>
+      <p:sp>
+        <p:nvSpPr>
+          <p:cNvPr id="19" name="Decorative s2-workflow-node-5" descr="" decorative="1">
+            <a:extLst>
+              <a:ext uri="{C183D7F6-B498-43B3-948B-1728B52AA6E4}">
+                <a16:decorative xmlns:a16="http://schemas.microsoft.com/office/drawing/2014/main">1</a16:decorative>
+              </a:ext>
+            </a:extLst>
+          </p:cNvPr>
+          <p:cNvSpPr/>
+          <p:nvPr/>
+        </p:nvSpPr>
+        <p:spPr>
+          <a:xfrm>
+            <a:off x="9308592" y="2359152"/>
+            <a:ext cx="1133856" cy="804672"/>
+          </a:xfrm>
+          <a:prstGeom prst="roundRect">
+            <a:avLst/>
+          </a:prstGeom>
+          <a:solidFill>
+            <a:srgbClr val="DCFCE7"/>
+          </a:solidFill>
+          <a:ln w="15240">
+            <a:solidFill>
+              <a:srgbClr val="059669"/>
+            </a:solidFill>
+            <a:prstDash val="solid"/>
+          </a:ln>
+        </p:spPr>
+      </p:sp>
+      <p:sp>
+        <p:nvSpPr>
+          <p:cNvPr id="20" name="Text 18"/>
+          <p:cNvSpPr/>
+          <p:nvPr/>
+        </p:nvSpPr>
+        <p:spPr>
+          <a:xfrm>
+            <a:off x="9308592" y="2587752"/>
+            <a:ext cx="1133856" cy="256032"/>
+          </a:xfrm>
+          <a:prstGeom prst="rect">
+            <a:avLst/>
+          </a:prstGeom>
+          <a:noFill/>
+          <a:ln/>
+        </p:spPr>
+        <p:txBody>
+          <a:bodyPr wrap="square" lIns="254" tIns="254" rIns="254" bIns="254" rtlCol="0" anchor="ctr">
+            <a:normAutofit/>
+          </a:bodyPr>
+          <a:lstStyle/>
+          <a:p>
+            <a:pPr algn="ctr" indent="0" marL="0">
+              <a:buNone/>
+            </a:pPr>
+            <a:r>
+              <a:rPr lang="en-US" sz="1500" dirty="0">
+                <a:solidFill>
+                  <a:srgbClr val="0F172A"/>
+                </a:solidFill>
+                <a:latin typeface="Yu Gothic" pitchFamily="34" charset="0"/>
+                <a:ea typeface="Yu Gothic" pitchFamily="34" charset="-122"/>
+                <a:cs typeface="Yu Gothic" pitchFamily="34" charset="-120"/>
+              </a:rPr>
+              <a:t>出力</a:t>
+            </a:r>
+            <a:endParaRPr lang="en-US" sz="1500" dirty="0"/>
+          </a:p>
+        </p:txBody>
+      </p:sp>
+      <p:sp>
+        <p:nvSpPr>
+          <p:cNvPr id="21" name="Text 19"/>
+          <p:cNvSpPr/>
+          <p:nvPr/>
+        </p:nvSpPr>
+        <p:spPr>
+          <a:xfrm>
+            <a:off x="950976" y="4261104"/>
+            <a:ext cx="9326880" cy="438912"/>
+          </a:xfrm>
+          <a:prstGeom prst="rect">
+            <a:avLst/>
+          </a:prstGeom>
+          <a:noFill/>
+          <a:ln/>
+        </p:spPr>
+        <p:txBody>
+          <a:bodyPr wrap="square" lIns="254" tIns="254" rIns="254" bIns="254" rtlCol="0" anchor="ctr">
+            <a:normAutofit/>
+          </a:bodyPr>
+          <a:lstStyle/>
+          <a:p>
+            <a:pPr indent="0" marL="0">
+              <a:buNone/>
+            </a:pPr>
+            <a:r>
+              <a:rPr lang="en-US" sz="2000" dirty="0">
+                <a:solidFill>
+                  <a:srgbClr val="334155"/>
+                </a:solidFill>
+                <a:latin typeface="Yu Gothic" pitchFamily="34" charset="0"/>
+                <a:ea typeface="Yu Gothic" pitchFamily="34" charset="-122"/>
+                <a:cs typeface="Yu Gothic" pitchFamily="34" charset="-120"/>
+              </a:rPr>
+              <a:t>ヒアリングで用途を固定し、DeckSpecに図・アイコン・検証条件を埋め込む</a:t>
+            </a:r>
+            <a:endParaRPr lang="en-US" sz="2000" dirty="0"/>
+          </a:p>
+        </p:txBody>
+      </p:sp>
+      <p:sp>
+        <p:nvSpPr>
+          <p:cNvPr id="22" name="Text 20"/>
           <p:cNvSpPr/>
           <p:nvPr/>
         </p:nvSpPr>
@@ -1594,39 +2527,564 @@
           </a:p>
         </p:txBody>
       </p:sp>
-      <p:pic>
-        <p:nvPicPr>
-          <p:cNvPr id="3" name="Image 0" descr="3秒テスト、視覚階層、アクセシビリティの3つの品質カード">    </p:cNvPr>
-          <p:cNvPicPr>
-            <a:picLocks noChangeAspect="1"/>
-          </p:cNvPicPr>
-          <p:nvPr/>
-        </p:nvPicPr>
-        <p:blipFill>
-          <a:blip r:embed="rId1">
+      <p:sp>
+        <p:nvSpPr>
+          <p:cNvPr id="3" name="Decorative s3-quality-card-0" descr="" decorative="1">
             <a:extLst>
-              <a:ext uri="{96DAC541-7B7A-43D3-8B79-37D633B846F1}">
-                <asvg:svgBlip xmlns:asvg="http://schemas.microsoft.com/office/drawing/2016/SVG/main" r:embed="rId2"/>
+              <a:ext uri="{C183D7F6-B498-43B3-948B-1728B52AA6E4}">
+                <a16:decorative xmlns:a16="http://schemas.microsoft.com/office/drawing/2014/main">1</a16:decorative>
               </a:ext>
             </a:extLst>
-          </a:blip>
-          <a:stretch>
-            <a:fillRect/>
-          </a:stretch>
-        </p:blipFill>
-        <p:spPr>
-          <a:xfrm>
-            <a:off x="685800" y="1298448"/>
-            <a:ext cx="10515600" cy="3566160"/>
-          </a:xfrm>
-          <a:prstGeom prst="rect">
-            <a:avLst/>
-          </a:prstGeom>
-        </p:spPr>
-      </p:pic>
-      <p:sp>
-        <p:nvSpPr>
-          <p:cNvPr id="4" name="Text 1"/>
+          </p:cNvPr>
+          <p:cNvSpPr/>
+          <p:nvPr/>
+        </p:nvSpPr>
+        <p:spPr>
+          <a:xfrm>
+            <a:off x="969264" y="1426464"/>
+            <a:ext cx="2743200" cy="2048256"/>
+          </a:xfrm>
+          <a:prstGeom prst="roundRect">
+            <a:avLst/>
+          </a:prstGeom>
+          <a:solidFill>
+            <a:srgbClr val="FFFFFF"/>
+          </a:solidFill>
+          <a:ln w="15240">
+            <a:solidFill>
+              <a:srgbClr val="CBD5E1"/>
+            </a:solidFill>
+            <a:prstDash val="solid"/>
+          </a:ln>
+        </p:spPr>
+      </p:sp>
+      <p:sp>
+        <p:nvSpPr>
+          <p:cNvPr id="4" name="Decorative s3-quality-icon-bg-0" descr="" decorative="1">
+            <a:extLst>
+              <a:ext uri="{C183D7F6-B498-43B3-948B-1728B52AA6E4}">
+                <a16:decorative xmlns:a16="http://schemas.microsoft.com/office/drawing/2014/main">1</a16:decorative>
+              </a:ext>
+            </a:extLst>
+          </p:cNvPr>
+          <p:cNvSpPr/>
+          <p:nvPr/>
+        </p:nvSpPr>
+        <p:spPr>
+          <a:xfrm>
+            <a:off x="1261872" y="1682496"/>
+            <a:ext cx="621792" cy="621792"/>
+          </a:xfrm>
+          <a:prstGeom prst="ellipse">
+            <a:avLst/>
+          </a:prstGeom>
+          <a:solidFill>
+            <a:srgbClr val="1D4ED8"/>
+          </a:solidFill>
+          <a:ln w="12700">
+            <a:solidFill>
+              <a:srgbClr val="1D4ED8"/>
+            </a:solidFill>
+            <a:prstDash val="solid"/>
+          </a:ln>
+        </p:spPr>
+      </p:sp>
+      <p:sp>
+        <p:nvSpPr>
+          <p:cNvPr id="5" name="Text 3"/>
+          <p:cNvSpPr/>
+          <p:nvPr/>
+        </p:nvSpPr>
+        <p:spPr>
+          <a:xfrm>
+            <a:off x="1261872" y="1773936"/>
+            <a:ext cx="621792" cy="310896"/>
+          </a:xfrm>
+          <a:prstGeom prst="rect">
+            <a:avLst/>
+          </a:prstGeom>
+          <a:noFill/>
+          <a:ln/>
+        </p:spPr>
+        <p:txBody>
+          <a:bodyPr wrap="square" lIns="254" tIns="254" rIns="254" bIns="254" rtlCol="0" anchor="ctr">
+            <a:normAutofit/>
+          </a:bodyPr>
+          <a:lstStyle/>
+          <a:p>
+            <a:pPr algn="ctr" indent="0" marL="0">
+              <a:buNone/>
+            </a:pPr>
+            <a:r>
+              <a:rPr lang="en-US" sz="2200" b="1" dirty="0">
+                <a:solidFill>
+                  <a:srgbClr val="FFFFFF"/>
+                </a:solidFill>
+                <a:latin typeface="Yu Gothic" pitchFamily="34" charset="0"/>
+                <a:ea typeface="Yu Gothic" pitchFamily="34" charset="-122"/>
+                <a:cs typeface="Yu Gothic" pitchFamily="34" charset="-120"/>
+              </a:rPr>
+              <a:t>D</a:t>
+            </a:r>
+            <a:endParaRPr lang="en-US" sz="2200" dirty="0"/>
+          </a:p>
+        </p:txBody>
+      </p:sp>
+      <p:sp>
+        <p:nvSpPr>
+          <p:cNvPr id="6" name="Text 4"/>
+          <p:cNvSpPr/>
+          <p:nvPr/>
+        </p:nvSpPr>
+        <p:spPr>
+          <a:xfrm>
+            <a:off x="1371600" y="2331720"/>
+            <a:ext cx="1920240" cy="347472"/>
+          </a:xfrm>
+          <a:prstGeom prst="rect">
+            <a:avLst/>
+          </a:prstGeom>
+          <a:noFill/>
+          <a:ln/>
+        </p:spPr>
+        <p:txBody>
+          <a:bodyPr wrap="square" lIns="254" tIns="254" rIns="254" bIns="254" rtlCol="0" anchor="ctr">
+            <a:normAutofit/>
+          </a:bodyPr>
+          <a:lstStyle/>
+          <a:p>
+            <a:pPr indent="0" marL="0">
+              <a:buNone/>
+            </a:pPr>
+            <a:r>
+              <a:rPr lang="en-US" sz="2000" b="1" dirty="0">
+                <a:solidFill>
+                  <a:srgbClr val="0F172A"/>
+                </a:solidFill>
+                <a:latin typeface="Yu Gothic" pitchFamily="34" charset="0"/>
+                <a:ea typeface="Yu Gothic" pitchFamily="34" charset="-122"/>
+                <a:cs typeface="Yu Gothic" pitchFamily="34" charset="-120"/>
+              </a:rPr>
+              <a:t>Decision</a:t>
+            </a:r>
+            <a:endParaRPr lang="en-US" sz="2000" dirty="0"/>
+          </a:p>
+        </p:txBody>
+      </p:sp>
+      <p:sp>
+        <p:nvSpPr>
+          <p:cNvPr id="7" name="Text 5"/>
+          <p:cNvSpPr/>
+          <p:nvPr/>
+        </p:nvSpPr>
+        <p:spPr>
+          <a:xfrm>
+            <a:off x="1371600" y="2834640"/>
+            <a:ext cx="2011680" cy="384048"/>
+          </a:xfrm>
+          <a:prstGeom prst="rect">
+            <a:avLst/>
+          </a:prstGeom>
+          <a:noFill/>
+          <a:ln/>
+        </p:spPr>
+        <p:txBody>
+          <a:bodyPr wrap="square" lIns="254" tIns="254" rIns="254" bIns="254" rtlCol="0" anchor="ctr">
+            <a:normAutofit/>
+          </a:bodyPr>
+          <a:lstStyle/>
+          <a:p>
+            <a:pPr indent="0" marL="0">
+              <a:buNone/>
+            </a:pPr>
+            <a:r>
+              <a:rPr lang="en-US" sz="1400" dirty="0">
+                <a:solidFill>
+                  <a:srgbClr val="334155"/>
+                </a:solidFill>
+                <a:latin typeface="Yu Gothic" pitchFamily="34" charset="0"/>
+                <a:ea typeface="Yu Gothic" pitchFamily="34" charset="-122"/>
+                <a:cs typeface="Yu Gothic" pitchFamily="34" charset="-120"/>
+              </a:rPr>
+              <a:t>判断事項を明確に</a:t>
+            </a:r>
+            <a:endParaRPr lang="en-US" sz="1400" dirty="0"/>
+          </a:p>
+        </p:txBody>
+      </p:sp>
+      <p:sp>
+        <p:nvSpPr>
+          <p:cNvPr id="8" name="Decorative s3-quality-card-1" descr="" decorative="1">
+            <a:extLst>
+              <a:ext uri="{C183D7F6-B498-43B3-948B-1728B52AA6E4}">
+                <a16:decorative xmlns:a16="http://schemas.microsoft.com/office/drawing/2014/main">1</a16:decorative>
+              </a:ext>
+            </a:extLst>
+          </p:cNvPr>
+          <p:cNvSpPr/>
+          <p:nvPr/>
+        </p:nvSpPr>
+        <p:spPr>
+          <a:xfrm>
+            <a:off x="4306824" y="1426464"/>
+            <a:ext cx="2743200" cy="2048256"/>
+          </a:xfrm>
+          <a:prstGeom prst="roundRect">
+            <a:avLst/>
+          </a:prstGeom>
+          <a:solidFill>
+            <a:srgbClr val="FFFFFF"/>
+          </a:solidFill>
+          <a:ln w="15240">
+            <a:solidFill>
+              <a:srgbClr val="CBD5E1"/>
+            </a:solidFill>
+            <a:prstDash val="solid"/>
+          </a:ln>
+        </p:spPr>
+      </p:sp>
+      <p:sp>
+        <p:nvSpPr>
+          <p:cNvPr id="9" name="Decorative s3-quality-icon-bg-1" descr="" decorative="1">
+            <a:extLst>
+              <a:ext uri="{C183D7F6-B498-43B3-948B-1728B52AA6E4}">
+                <a16:decorative xmlns:a16="http://schemas.microsoft.com/office/drawing/2014/main">1</a16:decorative>
+              </a:ext>
+            </a:extLst>
+          </p:cNvPr>
+          <p:cNvSpPr/>
+          <p:nvPr/>
+        </p:nvSpPr>
+        <p:spPr>
+          <a:xfrm>
+            <a:off x="4599432" y="1682496"/>
+            <a:ext cx="621792" cy="621792"/>
+          </a:xfrm>
+          <a:prstGeom prst="ellipse">
+            <a:avLst/>
+          </a:prstGeom>
+          <a:solidFill>
+            <a:srgbClr val="0F766E"/>
+          </a:solidFill>
+          <a:ln w="12700">
+            <a:solidFill>
+              <a:srgbClr val="0F766E"/>
+            </a:solidFill>
+            <a:prstDash val="solid"/>
+          </a:ln>
+        </p:spPr>
+      </p:sp>
+      <p:sp>
+        <p:nvSpPr>
+          <p:cNvPr id="10" name="Text 8"/>
+          <p:cNvSpPr/>
+          <p:nvPr/>
+        </p:nvSpPr>
+        <p:spPr>
+          <a:xfrm>
+            <a:off x="4599432" y="1773936"/>
+            <a:ext cx="621792" cy="310896"/>
+          </a:xfrm>
+          <a:prstGeom prst="rect">
+            <a:avLst/>
+          </a:prstGeom>
+          <a:noFill/>
+          <a:ln/>
+        </p:spPr>
+        <p:txBody>
+          <a:bodyPr wrap="square" lIns="254" tIns="254" rIns="254" bIns="254" rtlCol="0" anchor="ctr">
+            <a:normAutofit/>
+          </a:bodyPr>
+          <a:lstStyle/>
+          <a:p>
+            <a:pPr algn="ctr" indent="0" marL="0">
+              <a:buNone/>
+            </a:pPr>
+            <a:r>
+              <a:rPr lang="en-US" sz="2200" b="1" dirty="0">
+                <a:solidFill>
+                  <a:srgbClr val="FFFFFF"/>
+                </a:solidFill>
+                <a:latin typeface="Yu Gothic" pitchFamily="34" charset="0"/>
+                <a:ea typeface="Yu Gothic" pitchFamily="34" charset="-122"/>
+                <a:cs typeface="Yu Gothic" pitchFamily="34" charset="-120"/>
+              </a:rPr>
+              <a:t>R</a:t>
+            </a:r>
+            <a:endParaRPr lang="en-US" sz="2200" dirty="0"/>
+          </a:p>
+        </p:txBody>
+      </p:sp>
+      <p:sp>
+        <p:nvSpPr>
+          <p:cNvPr id="11" name="Text 9"/>
+          <p:cNvSpPr/>
+          <p:nvPr/>
+        </p:nvSpPr>
+        <p:spPr>
+          <a:xfrm>
+            <a:off x="4709160" y="2331720"/>
+            <a:ext cx="1920240" cy="347472"/>
+          </a:xfrm>
+          <a:prstGeom prst="rect">
+            <a:avLst/>
+          </a:prstGeom>
+          <a:noFill/>
+          <a:ln/>
+        </p:spPr>
+        <p:txBody>
+          <a:bodyPr wrap="square" lIns="254" tIns="254" rIns="254" bIns="254" rtlCol="0" anchor="ctr">
+            <a:normAutofit/>
+          </a:bodyPr>
+          <a:lstStyle/>
+          <a:p>
+            <a:pPr indent="0" marL="0">
+              <a:buNone/>
+            </a:pPr>
+            <a:r>
+              <a:rPr lang="en-US" sz="2000" b="1" dirty="0">
+                <a:solidFill>
+                  <a:srgbClr val="0F172A"/>
+                </a:solidFill>
+                <a:latin typeface="Yu Gothic" pitchFamily="34" charset="0"/>
+                <a:ea typeface="Yu Gothic" pitchFamily="34" charset="-122"/>
+                <a:cs typeface="Yu Gothic" pitchFamily="34" charset="-120"/>
+              </a:rPr>
+              <a:t>Risk</a:t>
+            </a:r>
+            <a:endParaRPr lang="en-US" sz="2000" dirty="0"/>
+          </a:p>
+        </p:txBody>
+      </p:sp>
+      <p:sp>
+        <p:nvSpPr>
+          <p:cNvPr id="12" name="Text 10"/>
+          <p:cNvSpPr/>
+          <p:nvPr/>
+        </p:nvSpPr>
+        <p:spPr>
+          <a:xfrm>
+            <a:off x="4709160" y="2834640"/>
+            <a:ext cx="2011680" cy="384048"/>
+          </a:xfrm>
+          <a:prstGeom prst="rect">
+            <a:avLst/>
+          </a:prstGeom>
+          <a:noFill/>
+          <a:ln/>
+        </p:spPr>
+        <p:txBody>
+          <a:bodyPr wrap="square" lIns="254" tIns="254" rIns="254" bIns="254" rtlCol="0" anchor="ctr">
+            <a:normAutofit/>
+          </a:bodyPr>
+          <a:lstStyle/>
+          <a:p>
+            <a:pPr indent="0" marL="0">
+              <a:buNone/>
+            </a:pPr>
+            <a:r>
+              <a:rPr lang="en-US" sz="1400" dirty="0">
+                <a:solidFill>
+                  <a:srgbClr val="334155"/>
+                </a:solidFill>
+                <a:latin typeface="Yu Gothic" pitchFamily="34" charset="0"/>
+                <a:ea typeface="Yu Gothic" pitchFamily="34" charset="-122"/>
+                <a:cs typeface="Yu Gothic" pitchFamily="34" charset="-120"/>
+              </a:rPr>
+              <a:t>リスクと代替案</a:t>
+            </a:r>
+            <a:endParaRPr lang="en-US" sz="1400" dirty="0"/>
+          </a:p>
+        </p:txBody>
+      </p:sp>
+      <p:sp>
+        <p:nvSpPr>
+          <p:cNvPr id="13" name="Decorative s3-quality-card-2" descr="" decorative="1">
+            <a:extLst>
+              <a:ext uri="{C183D7F6-B498-43B3-948B-1728B52AA6E4}">
+                <a16:decorative xmlns:a16="http://schemas.microsoft.com/office/drawing/2014/main">1</a16:decorative>
+              </a:ext>
+            </a:extLst>
+          </p:cNvPr>
+          <p:cNvSpPr/>
+          <p:nvPr/>
+        </p:nvSpPr>
+        <p:spPr>
+          <a:xfrm>
+            <a:off x="7644384" y="1426464"/>
+            <a:ext cx="2743200" cy="2048256"/>
+          </a:xfrm>
+          <a:prstGeom prst="roundRect">
+            <a:avLst/>
+          </a:prstGeom>
+          <a:solidFill>
+            <a:srgbClr val="FFFFFF"/>
+          </a:solidFill>
+          <a:ln w="15240">
+            <a:solidFill>
+              <a:srgbClr val="CBD5E1"/>
+            </a:solidFill>
+            <a:prstDash val="solid"/>
+          </a:ln>
+        </p:spPr>
+      </p:sp>
+      <p:sp>
+        <p:nvSpPr>
+          <p:cNvPr id="14" name="Decorative s3-quality-icon-bg-2" descr="" decorative="1">
+            <a:extLst>
+              <a:ext uri="{C183D7F6-B498-43B3-948B-1728B52AA6E4}">
+                <a16:decorative xmlns:a16="http://schemas.microsoft.com/office/drawing/2014/main">1</a16:decorative>
+              </a:ext>
+            </a:extLst>
+          </p:cNvPr>
+          <p:cNvSpPr/>
+          <p:nvPr/>
+        </p:nvSpPr>
+        <p:spPr>
+          <a:xfrm>
+            <a:off x="7936992" y="1682496"/>
+            <a:ext cx="621792" cy="621792"/>
+          </a:xfrm>
+          <a:prstGeom prst="ellipse">
+            <a:avLst/>
+          </a:prstGeom>
+          <a:solidFill>
+            <a:srgbClr val="7C3AED"/>
+          </a:solidFill>
+          <a:ln w="12700">
+            <a:solidFill>
+              <a:srgbClr val="7C3AED"/>
+            </a:solidFill>
+            <a:prstDash val="solid"/>
+          </a:ln>
+        </p:spPr>
+      </p:sp>
+      <p:sp>
+        <p:nvSpPr>
+          <p:cNvPr id="15" name="Text 13"/>
+          <p:cNvSpPr/>
+          <p:nvPr/>
+        </p:nvSpPr>
+        <p:spPr>
+          <a:xfrm>
+            <a:off x="7936992" y="1773936"/>
+            <a:ext cx="621792" cy="310896"/>
+          </a:xfrm>
+          <a:prstGeom prst="rect">
+            <a:avLst/>
+          </a:prstGeom>
+          <a:noFill/>
+          <a:ln/>
+        </p:spPr>
+        <p:txBody>
+          <a:bodyPr wrap="square" lIns="254" tIns="254" rIns="254" bIns="254" rtlCol="0" anchor="ctr">
+            <a:normAutofit/>
+          </a:bodyPr>
+          <a:lstStyle/>
+          <a:p>
+            <a:pPr algn="ctr" indent="0" marL="0">
+              <a:buNone/>
+            </a:pPr>
+            <a:r>
+              <a:rPr lang="en-US" sz="2200" b="1" dirty="0">
+                <a:solidFill>
+                  <a:srgbClr val="FFFFFF"/>
+                </a:solidFill>
+                <a:latin typeface="Yu Gothic" pitchFamily="34" charset="0"/>
+                <a:ea typeface="Yu Gothic" pitchFamily="34" charset="-122"/>
+                <a:cs typeface="Yu Gothic" pitchFamily="34" charset="-120"/>
+              </a:rPr>
+              <a:t>A</a:t>
+            </a:r>
+            <a:endParaRPr lang="en-US" sz="2200" dirty="0"/>
+          </a:p>
+        </p:txBody>
+      </p:sp>
+      <p:sp>
+        <p:nvSpPr>
+          <p:cNvPr id="16" name="Text 14"/>
+          <p:cNvSpPr/>
+          <p:nvPr/>
+        </p:nvSpPr>
+        <p:spPr>
+          <a:xfrm>
+            <a:off x="8046720" y="2331720"/>
+            <a:ext cx="1920240" cy="347472"/>
+          </a:xfrm>
+          <a:prstGeom prst="rect">
+            <a:avLst/>
+          </a:prstGeom>
+          <a:noFill/>
+          <a:ln/>
+        </p:spPr>
+        <p:txBody>
+          <a:bodyPr wrap="square" lIns="254" tIns="254" rIns="254" bIns="254" rtlCol="0" anchor="ctr">
+            <a:normAutofit/>
+          </a:bodyPr>
+          <a:lstStyle/>
+          <a:p>
+            <a:pPr indent="0" marL="0">
+              <a:buNone/>
+            </a:pPr>
+            <a:r>
+              <a:rPr lang="en-US" sz="2000" b="1" dirty="0">
+                <a:solidFill>
+                  <a:srgbClr val="0F172A"/>
+                </a:solidFill>
+                <a:latin typeface="Yu Gothic" pitchFamily="34" charset="0"/>
+                <a:ea typeface="Yu Gothic" pitchFamily="34" charset="-122"/>
+                <a:cs typeface="Yu Gothic" pitchFamily="34" charset="-120"/>
+              </a:rPr>
+              <a:t>Action</a:t>
+            </a:r>
+            <a:endParaRPr lang="en-US" sz="2000" dirty="0"/>
+          </a:p>
+        </p:txBody>
+      </p:sp>
+      <p:sp>
+        <p:nvSpPr>
+          <p:cNvPr id="17" name="Text 15"/>
+          <p:cNvSpPr/>
+          <p:nvPr/>
+        </p:nvSpPr>
+        <p:spPr>
+          <a:xfrm>
+            <a:off x="8046720" y="2834640"/>
+            <a:ext cx="2011680" cy="384048"/>
+          </a:xfrm>
+          <a:prstGeom prst="rect">
+            <a:avLst/>
+          </a:prstGeom>
+          <a:noFill/>
+          <a:ln/>
+        </p:spPr>
+        <p:txBody>
+          <a:bodyPr wrap="square" lIns="254" tIns="254" rIns="254" bIns="254" rtlCol="0" anchor="ctr">
+            <a:normAutofit/>
+          </a:bodyPr>
+          <a:lstStyle/>
+          <a:p>
+            <a:pPr indent="0" marL="0">
+              <a:buNone/>
+            </a:pPr>
+            <a:r>
+              <a:rPr lang="en-US" sz="1400" dirty="0">
+                <a:solidFill>
+                  <a:srgbClr val="334155"/>
+                </a:solidFill>
+                <a:latin typeface="Yu Gothic" pitchFamily="34" charset="0"/>
+                <a:ea typeface="Yu Gothic" pitchFamily="34" charset="-122"/>
+                <a:cs typeface="Yu Gothic" pitchFamily="34" charset="-120"/>
+              </a:rPr>
+              <a:t>次アクション</a:t>
+            </a:r>
+            <a:endParaRPr lang="en-US" sz="1400" dirty="0"/>
+          </a:p>
+        </p:txBody>
+      </p:sp>
+      <p:sp>
+        <p:nvSpPr>
+          <p:cNvPr id="18" name="Text 16"/>
           <p:cNvSpPr/>
           <p:nvPr/>
         </p:nvSpPr>
@@ -1738,69 +3196,674 @@
           </a:p>
         </p:txBody>
       </p:sp>
-      <p:pic>
-        <p:nvPicPr>
-          <p:cNvPr id="3" name="Image 0" descr="テンプレート、アイコン、ポンチ絵、lint、pptx出力の再利用パス">    </p:cNvPr>
-          <p:cNvPicPr>
-            <a:picLocks noChangeAspect="1"/>
-          </p:cNvPicPr>
-          <p:nvPr/>
-        </p:nvPicPr>
-        <p:blipFill>
-          <a:blip r:embed="rId1">
+      <p:sp>
+        <p:nvSpPr>
+          <p:cNvPr id="3" name="Decorative s4-rollout-base" descr="" decorative="1">
             <a:extLst>
-              <a:ext uri="{96DAC541-7B7A-43D3-8B79-37D633B846F1}">
-                <asvg:svgBlip xmlns:asvg="http://schemas.microsoft.com/office/drawing/2016/SVG/main" r:embed="rId2"/>
+              <a:ext uri="{C183D7F6-B498-43B3-948B-1728B52AA6E4}">
+                <a16:decorative xmlns:a16="http://schemas.microsoft.com/office/drawing/2014/main">1</a16:decorative>
               </a:ext>
             </a:extLst>
-          </a:blip>
-          <a:stretch>
-            <a:fillRect/>
-          </a:stretch>
-        </p:blipFill>
-        <p:spPr>
-          <a:xfrm>
-            <a:off x="685800" y="1234440"/>
-            <a:ext cx="10332720" cy="3611880"/>
-          </a:xfrm>
-          <a:prstGeom prst="rect">
-            <a:avLst/>
-          </a:prstGeom>
-        </p:spPr>
-      </p:pic>
-      <p:pic>
-        <p:nvPicPr>
-          <p:cNvPr id="4" name="Image 1" descr="アクセシビリティと安全性を示す盾アイコン">    </p:cNvPr>
-          <p:cNvPicPr>
-            <a:picLocks noChangeAspect="1"/>
-          </p:cNvPicPr>
-          <p:nvPr/>
-        </p:nvPicPr>
-        <p:blipFill>
-          <a:blip r:embed="rId3">
+          </p:cNvPr>
+          <p:cNvSpPr/>
+          <p:nvPr/>
+        </p:nvSpPr>
+        <p:spPr>
+          <a:xfrm>
+            <a:off x="960120" y="2761488"/>
+            <a:ext cx="9784080" cy="9144"/>
+          </a:xfrm>
+          <a:prstGeom prst="line">
+            <a:avLst/>
+          </a:prstGeom>
+          <a:ln w="101600">
+            <a:solidFill>
+              <a:srgbClr val="93C5FD"/>
+            </a:solidFill>
+            <a:prstDash val="solid"/>
+          </a:ln>
+        </p:spPr>
+      </p:sp>
+      <p:sp>
+        <p:nvSpPr>
+          <p:cNvPr id="4" name="Decorative s4-rollout-node-0" descr="" decorative="1">
             <a:extLst>
-              <a:ext uri="{96DAC541-7B7A-43D3-8B79-37D633B846F1}">
-                <asvg:svgBlip xmlns:asvg="http://schemas.microsoft.com/office/drawing/2016/SVG/main" r:embed="rId4"/>
+              <a:ext uri="{C183D7F6-B498-43B3-948B-1728B52AA6E4}">
+                <a16:decorative xmlns:a16="http://schemas.microsoft.com/office/drawing/2014/main">1</a16:decorative>
               </a:ext>
             </a:extLst>
-          </a:blip>
-          <a:stretch>
-            <a:fillRect/>
-          </a:stretch>
-        </p:blipFill>
+          </p:cNvPr>
+          <p:cNvSpPr/>
+          <p:nvPr/>
+        </p:nvSpPr>
+        <p:spPr>
+          <a:xfrm>
+            <a:off x="960120" y="2194560"/>
+            <a:ext cx="676656" cy="676656"/>
+          </a:xfrm>
+          <a:prstGeom prst="ellipse">
+            <a:avLst/>
+          </a:prstGeom>
+          <a:solidFill>
+            <a:srgbClr val="1D4ED8"/>
+          </a:solidFill>
+          <a:ln w="12700">
+            <a:solidFill>
+              <a:srgbClr val="1D4ED8"/>
+            </a:solidFill>
+            <a:prstDash val="solid"/>
+          </a:ln>
+        </p:spPr>
+      </p:sp>
+      <p:sp>
+        <p:nvSpPr>
+          <p:cNvPr id="5" name="Text 3"/>
+          <p:cNvSpPr/>
+          <p:nvPr/>
+        </p:nvSpPr>
+        <p:spPr>
+          <a:xfrm>
+            <a:off x="960120" y="2304288"/>
+            <a:ext cx="676656" cy="310896"/>
+          </a:xfrm>
+          <a:prstGeom prst="rect">
+            <a:avLst/>
+          </a:prstGeom>
+          <a:noFill/>
+          <a:ln/>
+        </p:spPr>
+        <p:txBody>
+          <a:bodyPr wrap="square" lIns="254" tIns="254" rIns="254" bIns="254" rtlCol="0" anchor="ctr">
+            <a:normAutofit/>
+          </a:bodyPr>
+          <a:lstStyle/>
+          <a:p>
+            <a:pPr algn="ctr" indent="0" marL="0">
+              <a:buNone/>
+            </a:pPr>
+            <a:r>
+              <a:rPr lang="en-US" sz="1700" dirty="0">
+                <a:solidFill>
+                  <a:srgbClr val="FFFFFF"/>
+                </a:solidFill>
+                <a:latin typeface="Yu Gothic" pitchFamily="34" charset="0"/>
+                <a:ea typeface="Yu Gothic" pitchFamily="34" charset="-122"/>
+                <a:cs typeface="Yu Gothic" pitchFamily="34" charset="-120"/>
+              </a:rPr>
+              <a:t>1</a:t>
+            </a:r>
+            <a:endParaRPr lang="en-US" sz="1700" dirty="0"/>
+          </a:p>
+        </p:txBody>
+      </p:sp>
+      <p:sp>
+        <p:nvSpPr>
+          <p:cNvPr id="6" name="Text 4"/>
+          <p:cNvSpPr/>
+          <p:nvPr/>
+        </p:nvSpPr>
+        <p:spPr>
+          <a:xfrm>
+            <a:off x="548640" y="2980944"/>
+            <a:ext cx="1536192" cy="292608"/>
+          </a:xfrm>
+          <a:prstGeom prst="rect">
+            <a:avLst/>
+          </a:prstGeom>
+          <a:noFill/>
+          <a:ln/>
+        </p:spPr>
+        <p:txBody>
+          <a:bodyPr wrap="square" lIns="254" tIns="254" rIns="254" bIns="254" rtlCol="0" anchor="ctr">
+            <a:normAutofit/>
+          </a:bodyPr>
+          <a:lstStyle/>
+          <a:p>
+            <a:pPr algn="ctr" indent="0" marL="0">
+              <a:buNone/>
+            </a:pPr>
+            <a:r>
+              <a:rPr lang="en-US" sz="1300" dirty="0">
+                <a:solidFill>
+                  <a:srgbClr val="0F172A"/>
+                </a:solidFill>
+                <a:latin typeface="Yu Gothic" pitchFamily="34" charset="0"/>
+                <a:ea typeface="Yu Gothic" pitchFamily="34" charset="-122"/>
+                <a:cs typeface="Yu Gothic" pitchFamily="34" charset="-120"/>
+              </a:rPr>
+              <a:t>論点</a:t>
+            </a:r>
+            <a:endParaRPr lang="en-US" sz="1300" dirty="0"/>
+          </a:p>
+        </p:txBody>
+      </p:sp>
+      <p:sp>
+        <p:nvSpPr>
+          <p:cNvPr id="7" name="Decorative s4-rollout-node-1" descr="" decorative="1">
+            <a:extLst>
+              <a:ext uri="{C183D7F6-B498-43B3-948B-1728B52AA6E4}">
+                <a16:decorative xmlns:a16="http://schemas.microsoft.com/office/drawing/2014/main">1</a16:decorative>
+              </a:ext>
+            </a:extLst>
+          </p:cNvPr>
+          <p:cNvSpPr/>
+          <p:nvPr/>
+        </p:nvSpPr>
+        <p:spPr>
+          <a:xfrm>
+            <a:off x="3264408" y="3200400"/>
+            <a:ext cx="676656" cy="676656"/>
+          </a:xfrm>
+          <a:prstGeom prst="ellipse">
+            <a:avLst/>
+          </a:prstGeom>
+          <a:solidFill>
+            <a:srgbClr val="1D4ED8"/>
+          </a:solidFill>
+          <a:ln w="12700">
+            <a:solidFill>
+              <a:srgbClr val="1D4ED8"/>
+            </a:solidFill>
+            <a:prstDash val="solid"/>
+          </a:ln>
+        </p:spPr>
+      </p:sp>
+      <p:sp>
+        <p:nvSpPr>
+          <p:cNvPr id="8" name="Text 6"/>
+          <p:cNvSpPr/>
+          <p:nvPr/>
+        </p:nvSpPr>
+        <p:spPr>
+          <a:xfrm>
+            <a:off x="3264408" y="3310128"/>
+            <a:ext cx="676656" cy="310896"/>
+          </a:xfrm>
+          <a:prstGeom prst="rect">
+            <a:avLst/>
+          </a:prstGeom>
+          <a:noFill/>
+          <a:ln/>
+        </p:spPr>
+        <p:txBody>
+          <a:bodyPr wrap="square" lIns="254" tIns="254" rIns="254" bIns="254" rtlCol="0" anchor="ctr">
+            <a:normAutofit/>
+          </a:bodyPr>
+          <a:lstStyle/>
+          <a:p>
+            <a:pPr algn="ctr" indent="0" marL="0">
+              <a:buNone/>
+            </a:pPr>
+            <a:r>
+              <a:rPr lang="en-US" sz="1700" dirty="0">
+                <a:solidFill>
+                  <a:srgbClr val="FFFFFF"/>
+                </a:solidFill>
+                <a:latin typeface="Yu Gothic" pitchFamily="34" charset="0"/>
+                <a:ea typeface="Yu Gothic" pitchFamily="34" charset="-122"/>
+                <a:cs typeface="Yu Gothic" pitchFamily="34" charset="-120"/>
+              </a:rPr>
+              <a:t>2</a:t>
+            </a:r>
+            <a:endParaRPr lang="en-US" sz="1700" dirty="0"/>
+          </a:p>
+        </p:txBody>
+      </p:sp>
+      <p:sp>
+        <p:nvSpPr>
+          <p:cNvPr id="9" name="Text 7"/>
+          <p:cNvSpPr/>
+          <p:nvPr/>
+        </p:nvSpPr>
+        <p:spPr>
+          <a:xfrm>
+            <a:off x="2852928" y="3986784"/>
+            <a:ext cx="1536192" cy="292608"/>
+          </a:xfrm>
+          <a:prstGeom prst="rect">
+            <a:avLst/>
+          </a:prstGeom>
+          <a:noFill/>
+          <a:ln/>
+        </p:spPr>
+        <p:txBody>
+          <a:bodyPr wrap="square" lIns="254" tIns="254" rIns="254" bIns="254" rtlCol="0" anchor="ctr">
+            <a:normAutofit/>
+          </a:bodyPr>
+          <a:lstStyle/>
+          <a:p>
+            <a:pPr algn="ctr" indent="0" marL="0">
+              <a:buNone/>
+            </a:pPr>
+            <a:r>
+              <a:rPr lang="en-US" sz="1300" dirty="0">
+                <a:solidFill>
+                  <a:srgbClr val="0F172A"/>
+                </a:solidFill>
+                <a:latin typeface="Yu Gothic" pitchFamily="34" charset="0"/>
+                <a:ea typeface="Yu Gothic" pitchFamily="34" charset="-122"/>
+                <a:cs typeface="Yu Gothic" pitchFamily="34" charset="-120"/>
+              </a:rPr>
+              <a:t>選択肢</a:t>
+            </a:r>
+            <a:endParaRPr lang="en-US" sz="1300" dirty="0"/>
+          </a:p>
+        </p:txBody>
+      </p:sp>
+      <p:sp>
+        <p:nvSpPr>
+          <p:cNvPr id="10" name="Decorative s4-rollout-node-2" descr="" decorative="1">
+            <a:extLst>
+              <a:ext uri="{C183D7F6-B498-43B3-948B-1728B52AA6E4}">
+                <a16:decorative xmlns:a16="http://schemas.microsoft.com/office/drawing/2014/main">1</a16:decorative>
+              </a:ext>
+            </a:extLst>
+          </p:cNvPr>
+          <p:cNvSpPr/>
+          <p:nvPr/>
+        </p:nvSpPr>
+        <p:spPr>
+          <a:xfrm>
+            <a:off x="5568696" y="2194560"/>
+            <a:ext cx="676656" cy="676656"/>
+          </a:xfrm>
+          <a:prstGeom prst="ellipse">
+            <a:avLst/>
+          </a:prstGeom>
+          <a:solidFill>
+            <a:srgbClr val="1D4ED8"/>
+          </a:solidFill>
+          <a:ln w="12700">
+            <a:solidFill>
+              <a:srgbClr val="1D4ED8"/>
+            </a:solidFill>
+            <a:prstDash val="solid"/>
+          </a:ln>
+        </p:spPr>
+      </p:sp>
+      <p:sp>
+        <p:nvSpPr>
+          <p:cNvPr id="11" name="Text 9"/>
+          <p:cNvSpPr/>
+          <p:nvPr/>
+        </p:nvSpPr>
+        <p:spPr>
+          <a:xfrm>
+            <a:off x="5568696" y="2304288"/>
+            <a:ext cx="676656" cy="310896"/>
+          </a:xfrm>
+          <a:prstGeom prst="rect">
+            <a:avLst/>
+          </a:prstGeom>
+          <a:noFill/>
+          <a:ln/>
+        </p:spPr>
+        <p:txBody>
+          <a:bodyPr wrap="square" lIns="254" tIns="254" rIns="254" bIns="254" rtlCol="0" anchor="ctr">
+            <a:normAutofit/>
+          </a:bodyPr>
+          <a:lstStyle/>
+          <a:p>
+            <a:pPr algn="ctr" indent="0" marL="0">
+              <a:buNone/>
+            </a:pPr>
+            <a:r>
+              <a:rPr lang="en-US" sz="1700" dirty="0">
+                <a:solidFill>
+                  <a:srgbClr val="FFFFFF"/>
+                </a:solidFill>
+                <a:latin typeface="Yu Gothic" pitchFamily="34" charset="0"/>
+                <a:ea typeface="Yu Gothic" pitchFamily="34" charset="-122"/>
+                <a:cs typeface="Yu Gothic" pitchFamily="34" charset="-120"/>
+              </a:rPr>
+              <a:t>3</a:t>
+            </a:r>
+            <a:endParaRPr lang="en-US" sz="1700" dirty="0"/>
+          </a:p>
+        </p:txBody>
+      </p:sp>
+      <p:sp>
+        <p:nvSpPr>
+          <p:cNvPr id="12" name="Text 10"/>
+          <p:cNvSpPr/>
+          <p:nvPr/>
+        </p:nvSpPr>
+        <p:spPr>
+          <a:xfrm>
+            <a:off x="5157216" y="2980944"/>
+            <a:ext cx="1536192" cy="292608"/>
+          </a:xfrm>
+          <a:prstGeom prst="rect">
+            <a:avLst/>
+          </a:prstGeom>
+          <a:noFill/>
+          <a:ln/>
+        </p:spPr>
+        <p:txBody>
+          <a:bodyPr wrap="square" lIns="254" tIns="254" rIns="254" bIns="254" rtlCol="0" anchor="ctr">
+            <a:normAutofit/>
+          </a:bodyPr>
+          <a:lstStyle/>
+          <a:p>
+            <a:pPr algn="ctr" indent="0" marL="0">
+              <a:buNone/>
+            </a:pPr>
+            <a:r>
+              <a:rPr lang="en-US" sz="1300" dirty="0">
+                <a:solidFill>
+                  <a:srgbClr val="0F172A"/>
+                </a:solidFill>
+                <a:latin typeface="Yu Gothic" pitchFamily="34" charset="0"/>
+                <a:ea typeface="Yu Gothic" pitchFamily="34" charset="-122"/>
+                <a:cs typeface="Yu Gothic" pitchFamily="34" charset="-120"/>
+              </a:rPr>
+              <a:t>リスク</a:t>
+            </a:r>
+            <a:endParaRPr lang="en-US" sz="1300" dirty="0"/>
+          </a:p>
+        </p:txBody>
+      </p:sp>
+      <p:sp>
+        <p:nvSpPr>
+          <p:cNvPr id="13" name="Decorative s4-rollout-node-3" descr="" decorative="1">
+            <a:extLst>
+              <a:ext uri="{C183D7F6-B498-43B3-948B-1728B52AA6E4}">
+                <a16:decorative xmlns:a16="http://schemas.microsoft.com/office/drawing/2014/main">1</a16:decorative>
+              </a:ext>
+            </a:extLst>
+          </p:cNvPr>
+          <p:cNvSpPr/>
+          <p:nvPr/>
+        </p:nvSpPr>
+        <p:spPr>
+          <a:xfrm>
+            <a:off x="7872984" y="3200400"/>
+            <a:ext cx="676656" cy="676656"/>
+          </a:xfrm>
+          <a:prstGeom prst="ellipse">
+            <a:avLst/>
+          </a:prstGeom>
+          <a:solidFill>
+            <a:srgbClr val="1D4ED8"/>
+          </a:solidFill>
+          <a:ln w="12700">
+            <a:solidFill>
+              <a:srgbClr val="1D4ED8"/>
+            </a:solidFill>
+            <a:prstDash val="solid"/>
+          </a:ln>
+        </p:spPr>
+      </p:sp>
+      <p:sp>
+        <p:nvSpPr>
+          <p:cNvPr id="14" name="Text 12"/>
+          <p:cNvSpPr/>
+          <p:nvPr/>
+        </p:nvSpPr>
+        <p:spPr>
+          <a:xfrm>
+            <a:off x="7872984" y="3310128"/>
+            <a:ext cx="676656" cy="310896"/>
+          </a:xfrm>
+          <a:prstGeom prst="rect">
+            <a:avLst/>
+          </a:prstGeom>
+          <a:noFill/>
+          <a:ln/>
+        </p:spPr>
+        <p:txBody>
+          <a:bodyPr wrap="square" lIns="254" tIns="254" rIns="254" bIns="254" rtlCol="0" anchor="ctr">
+            <a:normAutofit/>
+          </a:bodyPr>
+          <a:lstStyle/>
+          <a:p>
+            <a:pPr algn="ctr" indent="0" marL="0">
+              <a:buNone/>
+            </a:pPr>
+            <a:r>
+              <a:rPr lang="en-US" sz="1700" dirty="0">
+                <a:solidFill>
+                  <a:srgbClr val="FFFFFF"/>
+                </a:solidFill>
+                <a:latin typeface="Yu Gothic" pitchFamily="34" charset="0"/>
+                <a:ea typeface="Yu Gothic" pitchFamily="34" charset="-122"/>
+                <a:cs typeface="Yu Gothic" pitchFamily="34" charset="-120"/>
+              </a:rPr>
+              <a:t>4</a:t>
+            </a:r>
+            <a:endParaRPr lang="en-US" sz="1700" dirty="0"/>
+          </a:p>
+        </p:txBody>
+      </p:sp>
+      <p:sp>
+        <p:nvSpPr>
+          <p:cNvPr id="15" name="Text 13"/>
+          <p:cNvSpPr/>
+          <p:nvPr/>
+        </p:nvSpPr>
+        <p:spPr>
+          <a:xfrm>
+            <a:off x="7461504" y="3986784"/>
+            <a:ext cx="1536192" cy="292608"/>
+          </a:xfrm>
+          <a:prstGeom prst="rect">
+            <a:avLst/>
+          </a:prstGeom>
+          <a:noFill/>
+          <a:ln/>
+        </p:spPr>
+        <p:txBody>
+          <a:bodyPr wrap="square" lIns="254" tIns="254" rIns="254" bIns="254" rtlCol="0" anchor="ctr">
+            <a:normAutofit/>
+          </a:bodyPr>
+          <a:lstStyle/>
+          <a:p>
+            <a:pPr algn="ctr" indent="0" marL="0">
+              <a:buNone/>
+            </a:pPr>
+            <a:r>
+              <a:rPr lang="en-US" sz="1300" dirty="0">
+                <a:solidFill>
+                  <a:srgbClr val="0F172A"/>
+                </a:solidFill>
+                <a:latin typeface="Yu Gothic" pitchFamily="34" charset="0"/>
+                <a:ea typeface="Yu Gothic" pitchFamily="34" charset="-122"/>
+                <a:cs typeface="Yu Gothic" pitchFamily="34" charset="-120"/>
+              </a:rPr>
+              <a:t>推奨</a:t>
+            </a:r>
+            <a:endParaRPr lang="en-US" sz="1300" dirty="0"/>
+          </a:p>
+        </p:txBody>
+      </p:sp>
+      <p:sp>
+        <p:nvSpPr>
+          <p:cNvPr id="16" name="Decorative s4-rollout-node-4" descr="" decorative="1">
+            <a:extLst>
+              <a:ext uri="{C183D7F6-B498-43B3-948B-1728B52AA6E4}">
+                <a16:decorative xmlns:a16="http://schemas.microsoft.com/office/drawing/2014/main">1</a16:decorative>
+              </a:ext>
+            </a:extLst>
+          </p:cNvPr>
+          <p:cNvSpPr/>
+          <p:nvPr/>
+        </p:nvSpPr>
+        <p:spPr>
+          <a:xfrm>
+            <a:off x="10177272" y="2194560"/>
+            <a:ext cx="676656" cy="676656"/>
+          </a:xfrm>
+          <a:prstGeom prst="ellipse">
+            <a:avLst/>
+          </a:prstGeom>
+          <a:solidFill>
+            <a:srgbClr val="1D4ED8"/>
+          </a:solidFill>
+          <a:ln w="12700">
+            <a:solidFill>
+              <a:srgbClr val="1D4ED8"/>
+            </a:solidFill>
+            <a:prstDash val="solid"/>
+          </a:ln>
+        </p:spPr>
+      </p:sp>
+      <p:sp>
+        <p:nvSpPr>
+          <p:cNvPr id="17" name="Text 15"/>
+          <p:cNvSpPr/>
+          <p:nvPr/>
+        </p:nvSpPr>
+        <p:spPr>
+          <a:xfrm>
+            <a:off x="10177272" y="2304288"/>
+            <a:ext cx="676656" cy="310896"/>
+          </a:xfrm>
+          <a:prstGeom prst="rect">
+            <a:avLst/>
+          </a:prstGeom>
+          <a:noFill/>
+          <a:ln/>
+        </p:spPr>
+        <p:txBody>
+          <a:bodyPr wrap="square" lIns="254" tIns="254" rIns="254" bIns="254" rtlCol="0" anchor="ctr">
+            <a:normAutofit/>
+          </a:bodyPr>
+          <a:lstStyle/>
+          <a:p>
+            <a:pPr algn="ctr" indent="0" marL="0">
+              <a:buNone/>
+            </a:pPr>
+            <a:r>
+              <a:rPr lang="en-US" sz="1700" dirty="0">
+                <a:solidFill>
+                  <a:srgbClr val="FFFFFF"/>
+                </a:solidFill>
+                <a:latin typeface="Yu Gothic" pitchFamily="34" charset="0"/>
+                <a:ea typeface="Yu Gothic" pitchFamily="34" charset="-122"/>
+                <a:cs typeface="Yu Gothic" pitchFamily="34" charset="-120"/>
+              </a:rPr>
+              <a:t>5</a:t>
+            </a:r>
+            <a:endParaRPr lang="en-US" sz="1700" dirty="0"/>
+          </a:p>
+        </p:txBody>
+      </p:sp>
+      <p:sp>
+        <p:nvSpPr>
+          <p:cNvPr id="18" name="Text 16"/>
+          <p:cNvSpPr/>
+          <p:nvPr/>
+        </p:nvSpPr>
+        <p:spPr>
+          <a:xfrm>
+            <a:off x="9765792" y="2980944"/>
+            <a:ext cx="1536192" cy="292608"/>
+          </a:xfrm>
+          <a:prstGeom prst="rect">
+            <a:avLst/>
+          </a:prstGeom>
+          <a:noFill/>
+          <a:ln/>
+        </p:spPr>
+        <p:txBody>
+          <a:bodyPr wrap="square" lIns="254" tIns="254" rIns="254" bIns="254" rtlCol="0" anchor="ctr">
+            <a:normAutofit/>
+          </a:bodyPr>
+          <a:lstStyle/>
+          <a:p>
+            <a:pPr algn="ctr" indent="0" marL="0">
+              <a:buNone/>
+            </a:pPr>
+            <a:r>
+              <a:rPr lang="en-US" sz="1300" dirty="0">
+                <a:solidFill>
+                  <a:srgbClr val="0F172A"/>
+                </a:solidFill>
+                <a:latin typeface="Yu Gothic" pitchFamily="34" charset="0"/>
+                <a:ea typeface="Yu Gothic" pitchFamily="34" charset="-122"/>
+                <a:cs typeface="Yu Gothic" pitchFamily="34" charset="-120"/>
+              </a:rPr>
+              <a:t>決定</a:t>
+            </a:r>
+            <a:endParaRPr lang="en-US" sz="1300" dirty="0"/>
+          </a:p>
+        </p:txBody>
+      </p:sp>
+      <p:sp>
+        <p:nvSpPr>
+          <p:cNvPr id="19" name="Decorative s4-shield-badge" descr="" decorative="1">
+            <a:extLst>
+              <a:ext uri="{C183D7F6-B498-43B3-948B-1728B52AA6E4}">
+                <a16:decorative xmlns:a16="http://schemas.microsoft.com/office/drawing/2014/main">1</a16:decorative>
+              </a:ext>
+            </a:extLst>
+          </p:cNvPr>
+          <p:cNvSpPr/>
+          <p:nvPr/>
+        </p:nvSpPr>
         <p:spPr>
           <a:xfrm>
             <a:off x="804672" y="5330952"/>
             <a:ext cx="457200" cy="457200"/>
           </a:xfrm>
-          <a:prstGeom prst="rect">
-            <a:avLst/>
-          </a:prstGeom>
-        </p:spPr>
-      </p:pic>
-      <p:sp>
-        <p:nvSpPr>
-          <p:cNvPr id="5" name="Text 1"/>
+          <a:prstGeom prst="ellipse">
+            <a:avLst/>
+          </a:prstGeom>
+          <a:solidFill>
+            <a:srgbClr val="0F766E"/>
+          </a:solidFill>
+          <a:ln w="12700">
+            <a:solidFill>
+              <a:srgbClr val="0F766E"/>
+            </a:solidFill>
+            <a:prstDash val="solid"/>
+          </a:ln>
+        </p:spPr>
+      </p:sp>
+      <p:sp>
+        <p:nvSpPr>
+          <p:cNvPr id="20" name="Text 18"/>
+          <p:cNvSpPr/>
+          <p:nvPr/>
+        </p:nvSpPr>
+        <p:spPr>
+          <a:xfrm>
+            <a:off x="804672" y="5394960"/>
+            <a:ext cx="457200" cy="237744"/>
+          </a:xfrm>
+          <a:prstGeom prst="rect">
+            <a:avLst/>
+          </a:prstGeom>
+          <a:noFill/>
+          <a:ln/>
+        </p:spPr>
+        <p:txBody>
+          <a:bodyPr wrap="square" lIns="254" tIns="254" rIns="254" bIns="254" rtlCol="0" anchor="ctr">
+            <a:normAutofit/>
+          </a:bodyPr>
+          <a:lstStyle/>
+          <a:p>
+            <a:pPr algn="ctr" indent="0" marL="0">
+              <a:buNone/>
+            </a:pPr>
+            <a:r>
+              <a:rPr lang="en-US" sz="1600" dirty="0">
+                <a:solidFill>
+                  <a:srgbClr val="FFFFFF"/>
+                </a:solidFill>
+                <a:latin typeface="Yu Gothic" pitchFamily="34" charset="0"/>
+                <a:ea typeface="Yu Gothic" pitchFamily="34" charset="-122"/>
+                <a:cs typeface="Yu Gothic" pitchFamily="34" charset="-120"/>
+              </a:rPr>
+              <a:t>✓</a:t>
+            </a:r>
+            <a:endParaRPr lang="en-US" sz="1600" dirty="0"/>
+          </a:p>
+        </p:txBody>
+      </p:sp>
+      <p:sp>
+        <p:nvSpPr>
+          <p:cNvPr id="21" name="Text 19"/>
           <p:cNvSpPr/>
           <p:nvPr/>
         </p:nvSpPr>

</xml_diff>